<commit_message>
Publish narrated demo, submission assets and hosted verification
</commit_message>
<xml_diff>
--- a/output/kavu-pitch.pptx
+++ b/output/kavu-pitch.pptx
@@ -2,20 +2,20 @@
 <file path=ppt/presentation.xml><?xml version="1.0" encoding="utf-8"?>
 <p:presentation xmlns:p="http://schemas.openxmlformats.org/presentationml/2006/main">
   <p:sldMasterIdLst>
-    <p:sldMasterId xmlns:r="http://schemas.openxmlformats.org/officeDocument/2006/relationships" id="2147483648" r:id="R3befc193c81c4147"/>
+    <p:sldMasterId xmlns:r="http://schemas.openxmlformats.org/officeDocument/2006/relationships" id="2147483648" r:id="R93eafd8e91f14640"/>
   </p:sldMasterIdLst>
   <p:notesMasterIdLst>
-    <p:notesMasterId xmlns:r="http://schemas.openxmlformats.org/officeDocument/2006/relationships" r:id="R064c8f44bd8f4165"/>
+    <p:notesMasterId xmlns:r="http://schemas.openxmlformats.org/officeDocument/2006/relationships" r:id="R4f9b3af605044da8"/>
   </p:notesMasterIdLst>
   <p:sldIdLst>
-    <p:sldId xmlns:r="http://schemas.openxmlformats.org/officeDocument/2006/relationships" id="256" r:id="Raeaa20ccf06b4eb3"/>
-    <p:sldId xmlns:r="http://schemas.openxmlformats.org/officeDocument/2006/relationships" id="257" r:id="R2f1907fad46e406d"/>
-    <p:sldId xmlns:r="http://schemas.openxmlformats.org/officeDocument/2006/relationships" id="258" r:id="R0d3d13a2f1924b51"/>
-    <p:sldId xmlns:r="http://schemas.openxmlformats.org/officeDocument/2006/relationships" id="259" r:id="Rb175f6912b63458c"/>
-    <p:sldId xmlns:r="http://schemas.openxmlformats.org/officeDocument/2006/relationships" id="260" r:id="Red40956175324feb"/>
-    <p:sldId xmlns:r="http://schemas.openxmlformats.org/officeDocument/2006/relationships" id="261" r:id="Rb4f79a9cdf614852"/>
-    <p:sldId xmlns:r="http://schemas.openxmlformats.org/officeDocument/2006/relationships" id="262" r:id="R7db9ab05c89747ad"/>
-    <p:sldId xmlns:r="http://schemas.openxmlformats.org/officeDocument/2006/relationships" id="263" r:id="Rae99293194c4457f"/>
+    <p:sldId xmlns:r="http://schemas.openxmlformats.org/officeDocument/2006/relationships" id="256" r:id="R1b06a35ded654729"/>
+    <p:sldId xmlns:r="http://schemas.openxmlformats.org/officeDocument/2006/relationships" id="257" r:id="Rc62f2121f89c4a4a"/>
+    <p:sldId xmlns:r="http://schemas.openxmlformats.org/officeDocument/2006/relationships" id="258" r:id="R45632ccdeed048a2"/>
+    <p:sldId xmlns:r="http://schemas.openxmlformats.org/officeDocument/2006/relationships" id="259" r:id="R2ed98798d9ad46f5"/>
+    <p:sldId xmlns:r="http://schemas.openxmlformats.org/officeDocument/2006/relationships" id="260" r:id="Rb0cf915c5f6a406f"/>
+    <p:sldId xmlns:r="http://schemas.openxmlformats.org/officeDocument/2006/relationships" id="261" r:id="R7e891d54f9b84633"/>
+    <p:sldId xmlns:r="http://schemas.openxmlformats.org/officeDocument/2006/relationships" id="262" r:id="R4c2a957772dc46fb"/>
+    <p:sldId xmlns:r="http://schemas.openxmlformats.org/officeDocument/2006/relationships" id="263" r:id="R9812b7b5322c4aa0"/>
   </p:sldIdLst>
   <p:sldSz cx="12192000" cy="6858000"/>
   <p:notesSz cx="6858000" cy="9144000"/>
@@ -519,7 +519,7 @@
           <a:lstStyle xmlns:a="http://schemas.openxmlformats.org/drawingml/2006/main"/>
           <a:p xmlns:a="http://schemas.openxmlformats.org/drawingml/2006/main">
             <a:r>
-              <a:t>Problem framing is a product hypothesis, not a claim from interviews. KALRO 2021 Training of Trainers Manual, Module 10, printed pp60–64 (PDF pp72–76), covers drying, moisture for storage and practical use of moisture meters. https://keep.kalro.org/appfiles/media/vc_files/maize-tot.pdf . NCPB provides paid mechanical grain drying: https://ncpb.co.ke/drying/ . Kavu has no validated customer adoption or loss reduction at submission.</a:t>
+              <a:t>Problem framing is a product hypothesis, not a claim from interviews. KALRO 2021 Training of Trainers Manual, Module 10, printed pp60-64 (PDF pp72-76), covers drying, moisture for storage and practical use of moisture meters. https://keep.kalro.org/appfiles/media/vc_files/maize-tot.pdf . NCPB provides paid mechanical grain drying: https://ncpb.co.ke/drying/ . Kavu has no validated customer adoption or loss reduction at submission.</a:t>
             </a:r>
           </a:p>
         </p:txBody>
@@ -589,7 +589,7 @@
           <a:lstStyle xmlns:a="http://schemas.openxmlformats.org/drawingml/2006/main"/>
           <a:p xmlns:a="http://schemas.openxmlformats.org/drawingml/2006/main">
             <a:r>
-              <a:t>Derived source: data/processed/quality-report.json in the submitted repository. Input 21,189 rows, 18,364 unique, 2,825 duplicates removed. First 2026-08-28T00:00:25Z, last 2026-09-15T23:58:29Z. Gap 2026-09-04T23:58:18Z to 2026-09-11T00:00:01Z, 144.029h. The UI uses EAT; the date span here explicitly uses UTC. No interpolation crosses missing observations. Source files are organizer GeoCSV exports; official folder https://drive.google.com/drive/folders/1KDoCh8vss7nv_B6SuVBlQQssjSh1yaBg . Attribution: 3d-fewsnet.icdp.ucar.edu instrument61. DOI10.5065/D6V1236Q identifies CHORDS software, not a dataset DOI. Confirm redistribution and commercial terms with the owner before commercial deployment.</a:t>
+              <a:t>Derived source: data/processed/quality-report.json and docs/evaluation.md. Input21,189 rows,18,364 unique,2,825 overlapping rows removed. Observations span28August to15September2026UTC. Longestgap144.029hours. The controlled evaluation holds inventory, deadline, capacity and September12 planning date fixed and maps comparison weather timestamps to the same hour on that date. September12 allocates2700kg; September15 humid and September8 gap allocate0. This demonstrates functional data dependence and does not estimate forecast accuracy or field outcomes. Original source folder https://drive.google.com/drive/folders/1KDoCh8vss7nv_B6SuVBlQQssjSh1yaBg . Attribution https://3d-fewsnet.icdp.ucar.edu/instruments/61 . Data redistribution and commercial terms need owner confirmation.</a:t>
             </a:r>
           </a:p>
         </p:txBody>
@@ -729,7 +729,7 @@
           <a:lstStyle xmlns:a="http://schemas.openxmlformats.org/drawingml/2006/main"/>
           <a:p xmlns:a="http://schemas.openxmlformats.org/drawingml/2006/main">
             <a:r>
-              <a:t>Product methodology: deterministic operational rules use available temperature, relative humidity and rain plus capacity and lot metadata. Thresholds are configurable operating assumptions, not a trained drying model. Grain moisture comes from operator readings. Storage review requires a recent reading at or below the configured target. Moisture alone does not establish aflatoxin status or satisfy all buyer quality requirements. The historical replay is retrospective and cannot measure forecast performance. See shared domain engine and docs/methodology in final repository.</a:t>
+              <a:t>Architecture source: project implementation and deployment configuration. Firebase Hosting serves the React client, Cloud Run runs the Express API and a dedicated Firestore database persists cloud accounts, sessions and workspaces. SQLite remains the local self-hosting backend. Deployment verification status: implementation owner confirmed hosted checks. The current workspace has one account owner, not multi-operator role assignments. Demo workspaces are separate. Optional MET Norway forecast is separately attributed; historic Conduit observations do not calibrate it. Product direction Shivam Gupta; Codex-assisted engineering.</a:t>
             </a:r>
           </a:p>
         </p:txBody>
@@ -799,7 +799,7 @@
           <a:lstStyle xmlns:a="http://schemas.openxmlformats.org/drawingml/2006/main"/>
           <a:p xmlns:a="http://schemas.openxmlformats.org/drawingml/2006/main">
             <a:r>
-              <a:t>NCPB published reference tariff: KSh377.80 per1% moisture reduction per tonne, https://ncpb.co.ke/drying/ . We interpret a drop17% to15% as2 percentage points. Calculation5t×2pp×377.8=3778. The same NCPB page quotes18.90/50kg/pp; multiplying that rounded bag basis yields3780, a KSh2 rounding difference. Kavu uses the tonne basis consistently. Inputs are illustrative, not field observations. The tariff equivalent excludes actual handling/labour/transport, may differ from a depot quote, and is not verified savings, revenue or attributable impact.</a:t>
+              <a:t>NCPB published reference tariff: KSh377.80 per tonne per moisture percentage point, https://ncpb.co.ke/drying/ . Mavuno A-01 uses example intake mass1800kg, intake18.2%, follow-up15.0%. Calculation1.8x3.2x377.8=2176.128, displayed rounded KSh2176. Inputs are demonstration records, not field observations. This reference equivalent excludes actual labour, transport and handling, can differ from depot charges, and does not establish verified savings or causal impact. The ledger uses intake and latest moisture gap relative to target, rather than summing every downward reading.</a:t>
             </a:r>
           </a:p>
         </p:txBody>
@@ -1007,7 +1007,7 @@
   </p:cSld>
   <p:clrMap bg1="lt1" tx1="dk1" bg2="lt2" tx2="dk2" accent1="accent1" accent2="accent2" accent3="accent3" accent4="accent4" accent5="accent5" accent6="accent6" hlink="hlink" folHlink="folHlink"/>
   <p:sldLayoutIdLst>
-    <p:sldLayoutId xmlns:r="http://schemas.openxmlformats.org/officeDocument/2006/relationships" id="2147483649" r:id="Rcfbf047e26d04e56"/>
+    <p:sldLayoutId xmlns:r="http://schemas.openxmlformats.org/officeDocument/2006/relationships" id="2147483649" r:id="R0d08abb0e5fa4b8b"/>
   </p:sldLayoutIdLst>
   <p:txStyles>
     <p:titleStyle>
@@ -1555,10 +1555,10 @@
       </p:grpSpPr>
       <p:sp>
         <p:nvSpPr>
-          <p:cNvPr id="6" name="HACK THE WEATHER 2026">
+          <p:cNvPr id="7" name="HACK THE WEATHER 2026">
             <a:extLst xmlns:a="http://schemas.openxmlformats.org/drawingml/2006/main">
               <a:ext uri="{FF2B5EF4-FFF2-40B4-BE49-F238E27FC236}">
-                <a16:creationId xmlns:a16="http://schemas.microsoft.com/office/drawing/2014/main" id="{4D63F8CF-9201-4918-AFFE-E54A646EA2A6}"/>
+                <a16:creationId xmlns:a16="http://schemas.microsoft.com/office/drawing/2014/main" id="{12D25C4D-9D2F-4F7D-8B2D-2D40D3D21A11}"/>
               </a:ext>
             </a:extLst>
           </p:cNvPr>
@@ -1615,7 +1615,7 @@
           <p:cNvPr id="2" name="kavu.">
             <a:extLst xmlns:a="http://schemas.openxmlformats.org/drawingml/2006/main">
               <a:ext uri="{FF2B5EF4-FFF2-40B4-BE49-F238E27FC236}">
-                <a16:creationId xmlns:a16="http://schemas.microsoft.com/office/drawing/2014/main" id="{50077BDC-4794-477B-8123-21A544EDA211}"/>
+                <a16:creationId xmlns:a16="http://schemas.microsoft.com/office/drawing/2014/main" id="{C9C9E648-D799-4E51-AA5E-00D4CF222C49}"/>
               </a:ext>
             </a:extLst>
           </p:cNvPr>
@@ -1672,7 +1672,7 @@
           <p:cNvPr id="3" name="Every dry hour counts.">
             <a:extLst xmlns:a="http://schemas.openxmlformats.org/drawingml/2006/main">
               <a:ext uri="{FF2B5EF4-FFF2-40B4-BE49-F238E27FC236}">
-                <a16:creationId xmlns:a16="http://schemas.microsoft.com/office/drawing/2014/main" id="{A492778E-76C4-4BAD-A91B-5DF420A4B3DE}"/>
+                <a16:creationId xmlns:a16="http://schemas.microsoft.com/office/drawing/2014/main" id="{6AB0CDFD-DFBE-438E-9364-134EE45486A4}"/>
               </a:ext>
             </a:extLst>
           </p:cNvPr>
@@ -1729,7 +1729,7 @@
           <p:cNvPr id="4" name="A drying operations desk for maize cooperativ">
             <a:extLst xmlns:a="http://schemas.openxmlformats.org/drawingml/2006/main">
               <a:ext uri="{FF2B5EF4-FFF2-40B4-BE49-F238E27FC236}">
-                <a16:creationId xmlns:a16="http://schemas.microsoft.com/office/drawing/2014/main" id="{8015C84C-2753-4EC6-97AD-2B64D3733B52}"/>
+                <a16:creationId xmlns:a16="http://schemas.microsoft.com/office/drawing/2014/main" id="{EDBC730E-9562-4070-90CE-B3D2EA220607}"/>
               </a:ext>
             </a:extLst>
           </p:cNvPr>
@@ -1786,7 +1786,7 @@
           <p:cNvPr id="5" name="Shivam Gupta&#10;Founder and product lead">
             <a:extLst xmlns:a="http://schemas.openxmlformats.org/drawingml/2006/main">
               <a:ext uri="{FF2B5EF4-FFF2-40B4-BE49-F238E27FC236}">
-                <a16:creationId xmlns:a16="http://schemas.microsoft.com/office/drawing/2014/main" id="{ADE3EE67-20D3-4B06-819C-49D8B54B2608}"/>
+                <a16:creationId xmlns:a16="http://schemas.microsoft.com/office/drawing/2014/main" id="{8A31ABF4-CA40-4340-A345-54C5EDDD80A6}"/>
               </a:ext>
             </a:extLst>
           </p:cNvPr>
@@ -1797,8 +1797,8 @@
         </p:nvSpPr>
         <p:spPr>
           <a:xfrm xmlns:a="http://schemas.openxmlformats.org/drawingml/2006/main">
-            <a:off x="762000" y="5572125"/>
-            <a:ext cx="6667500" cy="609600"/>
+            <a:off x="762000" y="5495925"/>
+            <a:ext cx="5905500" cy="609600"/>
           </a:xfrm>
           <a:prstGeom xmlns:a="http://schemas.openxmlformats.org/drawingml/2006/main" prst="rect">
             <a:avLst/>
@@ -1861,10 +1861,67 @@
           </a:p>
         </p:txBody>
       </p:sp>
+      <p:sp>
+        <p:nvSpPr>
+          <p:cNvPr id="6" name="kavu-drying.web.app">
+            <a:extLst xmlns:a="http://schemas.openxmlformats.org/drawingml/2006/main">
+              <a:ext uri="{FF2B5EF4-FFF2-40B4-BE49-F238E27FC236}">
+                <a16:creationId xmlns:a16="http://schemas.microsoft.com/office/drawing/2014/main" id="{4CA81DEC-751F-41E3-888C-E76CF0F4AFA4}"/>
+              </a:ext>
+            </a:extLst>
+          </p:cNvPr>
+          <p:cNvSpPr>
+            <a:spLocks xmlns:a="http://schemas.openxmlformats.org/drawingml/2006/main" noGrp="1"/>
+          </p:cNvSpPr>
+          <p:nvPr/>
+        </p:nvSpPr>
+        <p:spPr>
+          <a:xfrm xmlns:a="http://schemas.openxmlformats.org/drawingml/2006/main">
+            <a:off x="762000" y="6219825"/>
+            <a:ext cx="10001250" cy="304800"/>
+          </a:xfrm>
+          <a:prstGeom xmlns:a="http://schemas.openxmlformats.org/drawingml/2006/main" prst="rect">
+            <a:avLst/>
+          </a:prstGeom>
+          <a:noFill xmlns:a="http://schemas.openxmlformats.org/drawingml/2006/main"/>
+          <a:ln xmlns:a="http://schemas.openxmlformats.org/drawingml/2006/main" w="0">
+            <a:noFill/>
+          </a:ln>
+        </p:spPr>
+        <p:txBody>
+          <a:bodyPr xmlns:a="http://schemas.openxmlformats.org/drawingml/2006/main" wrap="square" lIns="0" tIns="0" rIns="0" bIns="0">
+            <a:noAutofit/>
+          </a:bodyPr>
+          <a:lstStyle xmlns:a="http://schemas.openxmlformats.org/drawingml/2006/main"/>
+          <a:p xmlns:a="http://schemas.openxmlformats.org/drawingml/2006/main">
+            <a:pPr>
+              <a:defRPr sz="1725" b="1">
+                <a:solidFill>
+                  <a:srgbClr val="D0A650"/>
+                </a:solidFill>
+                <a:latin typeface="DM Sans"/>
+                <a:ea typeface="DM Sans"/>
+                <a:cs typeface="DM Sans"/>
+              </a:defRPr>
+            </a:pPr>
+            <a:r>
+              <a:rPr sz="1725" b="1">
+                <a:solidFill>
+                  <a:srgbClr val="D0A650"/>
+                </a:solidFill>
+                <a:latin typeface="DM Sans"/>
+                <a:ea typeface="DM Sans"/>
+                <a:cs typeface="DM Sans"/>
+              </a:rPr>
+              <a:t>kavu-drying.web.app</a:t>
+            </a:r>
+          </a:p>
+        </p:txBody>
+      </p:sp>
     </p:spTree>
     <p:extLst>
       <p:ext uri="{BB962C8B-B14F-4D97-AF65-F5344CB8AC3E}">
-        <p14:creationId xmlns:p14="http://schemas.microsoft.com/office/powerpoint/2010/main" val="903322596"/>
+        <p14:creationId xmlns:p14="http://schemas.microsoft.com/office/powerpoint/2010/main" val="136436261"/>
       </p:ext>
     </p:extLst>
   </p:cSld>
@@ -1895,7 +1952,7 @@
           <p:cNvPr id="10" name="The work after the weather report">
             <a:extLst xmlns:a="http://schemas.openxmlformats.org/drawingml/2006/main">
               <a:ext uri="{FF2B5EF4-FFF2-40B4-BE49-F238E27FC236}">
-                <a16:creationId xmlns:a16="http://schemas.microsoft.com/office/drawing/2014/main" id="{E36ADD04-B322-4C02-AF6C-C0A0A25CA386}"/>
+                <a16:creationId xmlns:a16="http://schemas.microsoft.com/office/drawing/2014/main" id="{48FEFF08-7AB0-4BEE-946A-A543B6C33ADA}"/>
               </a:ext>
             </a:extLst>
           </p:cNvPr>
@@ -1952,7 +2009,7 @@
           <p:cNvPr id="2" name="Which lot&#10;needs action&#10;next?">
             <a:extLst xmlns:a="http://schemas.openxmlformats.org/drawingml/2006/main">
               <a:ext uri="{FF2B5EF4-FFF2-40B4-BE49-F238E27FC236}">
-                <a16:creationId xmlns:a16="http://schemas.microsoft.com/office/drawing/2014/main" id="{FEEB1940-CB6E-4361-8B8F-62D74CB7EBB4}"/>
+                <a16:creationId xmlns:a16="http://schemas.microsoft.com/office/drawing/2014/main" id="{2D9FE348-7C05-4CFD-90BB-D2CF9C5694F6}"/>
               </a:ext>
             </a:extLst>
           </p:cNvPr>
@@ -2055,7 +2112,7 @@
           <p:cNvPr id="3" name="Spread and turn">
             <a:extLst xmlns:a="http://schemas.openxmlformats.org/drawingml/2006/main">
               <a:ext uri="{FF2B5EF4-FFF2-40B4-BE49-F238E27FC236}">
-                <a16:creationId xmlns:a16="http://schemas.microsoft.com/office/drawing/2014/main" id="{9C664D53-9D07-4EE6-A620-0CC2CAC6BA71}"/>
+                <a16:creationId xmlns:a16="http://schemas.microsoft.com/office/drawing/2014/main" id="{DAF75EB9-6649-4D66-9B01-CEE534D3A499}"/>
               </a:ext>
             </a:extLst>
           </p:cNvPr>
@@ -2112,7 +2169,7 @@
           <p:cNvPr id="4" name="Use the available yard and operator time.">
             <a:extLst xmlns:a="http://schemas.openxmlformats.org/drawingml/2006/main">
               <a:ext uri="{FF2B5EF4-FFF2-40B4-BE49-F238E27FC236}">
-                <a16:creationId xmlns:a16="http://schemas.microsoft.com/office/drawing/2014/main" id="{99F8DF17-1DFC-4E4B-A933-7010749C6009}"/>
+                <a16:creationId xmlns:a16="http://schemas.microsoft.com/office/drawing/2014/main" id="{AE3C0EF8-709C-4BE8-81D8-2BE34520CD18}"/>
               </a:ext>
             </a:extLst>
           </p:cNvPr>
@@ -2169,7 +2226,7 @@
           <p:cNvPr id="5" name="Cover or seek a dryer">
             <a:extLst xmlns:a="http://schemas.openxmlformats.org/drawingml/2006/main">
               <a:ext uri="{FF2B5EF4-FFF2-40B4-BE49-F238E27FC236}">
-                <a16:creationId xmlns:a16="http://schemas.microsoft.com/office/drawing/2014/main" id="{4127E1FB-FF5E-4330-B579-578C9F0F9880}"/>
+                <a16:creationId xmlns:a16="http://schemas.microsoft.com/office/drawing/2014/main" id="{C8DDCB11-AE53-4FEB-8DD4-04B4CB7A2F84}"/>
               </a:ext>
             </a:extLst>
           </p:cNvPr>
@@ -2226,7 +2283,7 @@
           <p:cNvPr id="6" name="Respond when the weather changes.">
             <a:extLst xmlns:a="http://schemas.openxmlformats.org/drawingml/2006/main">
               <a:ext uri="{FF2B5EF4-FFF2-40B4-BE49-F238E27FC236}">
-                <a16:creationId xmlns:a16="http://schemas.microsoft.com/office/drawing/2014/main" id="{C790CB2F-958E-4E19-84D9-7745726F3CB4}"/>
+                <a16:creationId xmlns:a16="http://schemas.microsoft.com/office/drawing/2014/main" id="{82406BD1-24AB-4203-A136-9C5A12EA9202}"/>
               </a:ext>
             </a:extLst>
           </p:cNvPr>
@@ -2283,7 +2340,7 @@
           <p:cNvPr id="7" name="Measure again">
             <a:extLst xmlns:a="http://schemas.openxmlformats.org/drawingml/2006/main">
               <a:ext uri="{FF2B5EF4-FFF2-40B4-BE49-F238E27FC236}">
-                <a16:creationId xmlns:a16="http://schemas.microsoft.com/office/drawing/2014/main" id="{BD2ACDD5-0DF4-4A70-8D6A-3A2B42597381}"/>
+                <a16:creationId xmlns:a16="http://schemas.microsoft.com/office/drawing/2014/main" id="{2A5148F7-E9DC-45DB-9561-5C605E702FC5}"/>
               </a:ext>
             </a:extLst>
           </p:cNvPr>
@@ -2340,7 +2397,7 @@
           <p:cNvPr id="8" name="A new reading decides the next step.">
             <a:extLst xmlns:a="http://schemas.openxmlformats.org/drawingml/2006/main">
               <a:ext uri="{FF2B5EF4-FFF2-40B4-BE49-F238E27FC236}">
-                <a16:creationId xmlns:a16="http://schemas.microsoft.com/office/drawing/2014/main" id="{566E9944-CF0D-4994-981C-0A202E5E28B8}"/>
+                <a16:creationId xmlns:a16="http://schemas.microsoft.com/office/drawing/2014/main" id="{E3E29871-2CE9-42F0-A71D-0DD5A8903C9B}"/>
               </a:ext>
             </a:extLst>
           </p:cNvPr>
@@ -2397,7 +2454,7 @@
           <p:cNvPr id="9" name="Kavu    02">
             <a:extLst xmlns:a="http://schemas.openxmlformats.org/drawingml/2006/main">
               <a:ext uri="{FF2B5EF4-FFF2-40B4-BE49-F238E27FC236}">
-                <a16:creationId xmlns:a16="http://schemas.microsoft.com/office/drawing/2014/main" id="{DC5FDF42-5357-487B-8D50-15A715EA418D}"/>
+                <a16:creationId xmlns:a16="http://schemas.microsoft.com/office/drawing/2014/main" id="{958621FC-4342-4F85-A435-400CA466FBAC}"/>
               </a:ext>
             </a:extLst>
           </p:cNvPr>
@@ -2452,7 +2509,7 @@
     </p:spTree>
     <p:extLst>
       <p:ext uri="{BB962C8B-B14F-4D97-AF65-F5344CB8AC3E}">
-        <p14:creationId xmlns:p14="http://schemas.microsoft.com/office/powerpoint/2010/main" val="2073933236"/>
+        <p14:creationId xmlns:p14="http://schemas.microsoft.com/office/powerpoint/2010/main" val="1171318589"/>
       </p:ext>
     </p:extLst>
   </p:cSld>
@@ -2480,10 +2537,10 @@
       </p:grpSpPr>
       <p:sp>
         <p:nvSpPr>
-          <p:cNvPr id="9" name="Real observations, visible limits">
+          <p:cNvPr id="10" name="Conduit changes the work plan">
             <a:extLst xmlns:a="http://schemas.openxmlformats.org/drawingml/2006/main">
               <a:ext uri="{FF2B5EF4-FFF2-40B4-BE49-F238E27FC236}">
-                <a16:creationId xmlns:a16="http://schemas.microsoft.com/office/drawing/2014/main" id="{FB7CE558-4FCE-4414-A879-A00A95D3FED0}"/>
+                <a16:creationId xmlns:a16="http://schemas.microsoft.com/office/drawing/2014/main" id="{27517AA6-26BB-4B34-8452-86DC8006C4F0}"/>
               </a:ext>
             </a:extLst>
           </p:cNvPr>
@@ -2530,7 +2587,7 @@
                 <a:ea typeface="Manrope"/>
                 <a:cs typeface="Manrope"/>
               </a:rPr>
-              <a:t>Real observations, visible limits</a:t>
+              <a:t>Conduit changes the work plan</a:t>
             </a:r>
           </a:p>
         </p:txBody>
@@ -2540,7 +2597,7 @@
           <p:cNvPr id="2" name="18,364">
             <a:extLst xmlns:a="http://schemas.openxmlformats.org/drawingml/2006/main">
               <a:ext uri="{FF2B5EF4-FFF2-40B4-BE49-F238E27FC236}">
-                <a16:creationId xmlns:a16="http://schemas.microsoft.com/office/drawing/2014/main" id="{66CAB8AB-43AA-4BFE-B8C1-A4A137E2BDA5}"/>
+                <a16:creationId xmlns:a16="http://schemas.microsoft.com/office/drawing/2014/main" id="{37EA1F1A-F982-4B9D-B933-7EDB78B29706}"/>
               </a:ext>
             </a:extLst>
           </p:cNvPr>
@@ -2551,8 +2608,8 @@
         </p:nvSpPr>
         <p:spPr>
           <a:xfrm xmlns:a="http://schemas.openxmlformats.org/drawingml/2006/main">
-            <a:off x="685800" y="2009775"/>
-            <a:ext cx="5715000" cy="1047750"/>
+            <a:off x="723900" y="1809750"/>
+            <a:ext cx="5524500" cy="876300"/>
           </a:xfrm>
           <a:prstGeom xmlns:a="http://schemas.openxmlformats.org/drawingml/2006/main" prst="rect">
             <a:avLst/>
@@ -2569,7 +2626,7 @@
           <a:lstStyle xmlns:a="http://schemas.openxmlformats.org/drawingml/2006/main"/>
           <a:p xmlns:a="http://schemas.openxmlformats.org/drawingml/2006/main">
             <a:pPr>
-              <a:defRPr sz="7125" b="1">
+              <a:defRPr sz="5700" b="1">
                 <a:solidFill>
                   <a:srgbClr val="F8F9F5"/>
                 </a:solidFill>
@@ -2579,7 +2636,7 @@
               </a:defRPr>
             </a:pPr>
             <a:r>
-              <a:rPr sz="7125" b="1">
+              <a:rPr sz="5700" b="1">
                 <a:solidFill>
                   <a:srgbClr val="F8F9F5"/>
                 </a:solidFill>
@@ -2594,10 +2651,10 @@
       </p:sp>
       <p:sp>
         <p:nvSpPr>
-          <p:cNvPr id="3" name="unique Conduit observations">
+          <p:cNvPr id="3" name="unique observations with traceable sources">
             <a:extLst xmlns:a="http://schemas.openxmlformats.org/drawingml/2006/main">
               <a:ext uri="{FF2B5EF4-FFF2-40B4-BE49-F238E27FC236}">
-                <a16:creationId xmlns:a16="http://schemas.microsoft.com/office/drawing/2014/main" id="{5D6E3332-C0B2-4023-8594-51D7C141CAAB}"/>
+                <a16:creationId xmlns:a16="http://schemas.microsoft.com/office/drawing/2014/main" id="{A21E7078-63E5-4071-A256-A062FCDCE3BC}"/>
               </a:ext>
             </a:extLst>
           </p:cNvPr>
@@ -2608,8 +2665,8 @@
         </p:nvSpPr>
         <p:spPr>
           <a:xfrm xmlns:a="http://schemas.openxmlformats.org/drawingml/2006/main">
-            <a:off x="742950" y="3124200"/>
-            <a:ext cx="6191250" cy="457200"/>
+            <a:off x="752475" y="2800350"/>
+            <a:ext cx="9906000" cy="400050"/>
           </a:xfrm>
           <a:prstGeom xmlns:a="http://schemas.openxmlformats.org/drawingml/2006/main" prst="rect">
             <a:avLst/>
@@ -2626,7 +2683,7 @@
           <a:lstStyle xmlns:a="http://schemas.openxmlformats.org/drawingml/2006/main"/>
           <a:p xmlns:a="http://schemas.openxmlformats.org/drawingml/2006/main">
             <a:pPr>
-              <a:defRPr sz="2100" b="0">
+              <a:defRPr sz="2025" b="0">
                 <a:solidFill>
                   <a:srgbClr val="DEE5D9"/>
                 </a:solidFill>
@@ -2636,7 +2693,7 @@
               </a:defRPr>
             </a:pPr>
             <a:r>
-              <a:rPr sz="2100" b="0">
+              <a:rPr sz="2025" b="0">
                 <a:solidFill>
                   <a:srgbClr val="DEE5D9"/>
                 </a:solidFill>
@@ -2644,17 +2701,17 @@
                 <a:ea typeface="DM Sans"/>
                 <a:cs typeface="DM Sans"/>
               </a:rPr>
-              <a:t>unique Conduit observations</a:t>
-            </a:r>
-          </a:p>
-        </p:txBody>
-      </p:sp>
-      <p:sp>
-        <p:nvSpPr>
-          <p:cNvPr id="4" name="2,825">
+              <a:t>unique observations with traceable sources</a:t>
+            </a:r>
+          </a:p>
+        </p:txBody>
+      </p:sp>
+      <p:sp>
+        <p:nvSpPr>
+          <p:cNvPr id="4" name="2,700 kg">
             <a:extLst xmlns:a="http://schemas.openxmlformats.org/drawingml/2006/main">
               <a:ext uri="{FF2B5EF4-FFF2-40B4-BE49-F238E27FC236}">
-                <a16:creationId xmlns:a16="http://schemas.microsoft.com/office/drawing/2014/main" id="{226948BB-3C4C-4266-844C-A6EBEFC85742}"/>
+                <a16:creationId xmlns:a16="http://schemas.microsoft.com/office/drawing/2014/main" id="{8FDC3751-74A5-477A-8F58-9841E8023024}"/>
               </a:ext>
             </a:extLst>
           </p:cNvPr>
@@ -2665,8 +2722,8 @@
         </p:nvSpPr>
         <p:spPr>
           <a:xfrm xmlns:a="http://schemas.openxmlformats.org/drawingml/2006/main">
-            <a:off x="7620000" y="2124075"/>
-            <a:ext cx="3714750" cy="838200"/>
+            <a:off x="733425" y="3867150"/>
+            <a:ext cx="5619750" cy="781050"/>
           </a:xfrm>
           <a:prstGeom xmlns:a="http://schemas.openxmlformats.org/drawingml/2006/main" prst="rect">
             <a:avLst/>
@@ -2683,7 +2740,7 @@
           <a:lstStyle xmlns:a="http://schemas.openxmlformats.org/drawingml/2006/main"/>
           <a:p xmlns:a="http://schemas.openxmlformats.org/drawingml/2006/main">
             <a:pPr>
-              <a:defRPr sz="5250" b="1">
+              <a:defRPr sz="4800" b="1">
                 <a:solidFill>
                   <a:srgbClr val="D0A650"/>
                 </a:solidFill>
@@ -2693,7 +2750,7 @@
               </a:defRPr>
             </a:pPr>
             <a:r>
-              <a:rPr sz="5250" b="1">
+              <a:rPr sz="4800" b="1">
                 <a:solidFill>
                   <a:srgbClr val="D0A650"/>
                 </a:solidFill>
@@ -2701,17 +2758,17 @@
                 <a:ea typeface="Manrope"/>
                 <a:cs typeface="Manrope"/>
               </a:rPr>
-              <a:t>2,825</a:t>
-            </a:r>
-          </a:p>
-        </p:txBody>
-      </p:sp>
-      <p:sp>
-        <p:nvSpPr>
-          <p:cNvPr id="5" name="duplicate rows removed">
+              <a:t>2,700 kg</a:t>
+            </a:r>
+          </a:p>
+        </p:txBody>
+      </p:sp>
+      <p:sp>
+        <p:nvSpPr>
+          <p:cNvPr id="5" name="12 September: outdoor allocation">
             <a:extLst xmlns:a="http://schemas.openxmlformats.org/drawingml/2006/main">
               <a:ext uri="{FF2B5EF4-FFF2-40B4-BE49-F238E27FC236}">
-                <a16:creationId xmlns:a16="http://schemas.microsoft.com/office/drawing/2014/main" id="{E28F4998-9ACD-4D51-AF1E-79DBE08EFAD6}"/>
+                <a16:creationId xmlns:a16="http://schemas.microsoft.com/office/drawing/2014/main" id="{825D6652-1564-4E28-B959-8C864D1FC1A9}"/>
               </a:ext>
             </a:extLst>
           </p:cNvPr>
@@ -2722,8 +2779,8 @@
         </p:nvSpPr>
         <p:spPr>
           <a:xfrm xmlns:a="http://schemas.openxmlformats.org/drawingml/2006/main">
-            <a:off x="7648575" y="3124200"/>
-            <a:ext cx="3571875" cy="590550"/>
+            <a:off x="762000" y="4752975"/>
+            <a:ext cx="5429250" cy="438150"/>
           </a:xfrm>
           <a:prstGeom xmlns:a="http://schemas.openxmlformats.org/drawingml/2006/main" prst="rect">
             <a:avLst/>
@@ -2740,7 +2797,7 @@
           <a:lstStyle xmlns:a="http://schemas.openxmlformats.org/drawingml/2006/main"/>
           <a:p xmlns:a="http://schemas.openxmlformats.org/drawingml/2006/main">
             <a:pPr>
-              <a:defRPr sz="1875" b="0">
+              <a:defRPr sz="1950" b="0">
                 <a:solidFill>
                   <a:srgbClr val="DEE5D9"/>
                 </a:solidFill>
@@ -2750,7 +2807,7 @@
               </a:defRPr>
             </a:pPr>
             <a:r>
-              <a:rPr sz="1875" b="0">
+              <a:rPr sz="1950" b="0">
                 <a:solidFill>
                   <a:srgbClr val="DEE5D9"/>
                 </a:solidFill>
@@ -2758,17 +2815,17 @@
                 <a:ea typeface="DM Sans"/>
                 <a:cs typeface="DM Sans"/>
               </a:rPr>
-              <a:t>duplicate rows removed</a:t>
-            </a:r>
-          </a:p>
-        </p:txBody>
-      </p:sp>
-      <p:sp>
-        <p:nvSpPr>
-          <p:cNvPr id="6" name="28 Aug–15 Sep 2026 UTC">
+              <a:t>12 September: outdoor allocation</a:t>
+            </a:r>
+          </a:p>
+        </p:txBody>
+      </p:sp>
+      <p:sp>
+        <p:nvSpPr>
+          <p:cNvPr id="6" name="0 kg">
             <a:extLst xmlns:a="http://schemas.openxmlformats.org/drawingml/2006/main">
               <a:ext uri="{FF2B5EF4-FFF2-40B4-BE49-F238E27FC236}">
-                <a16:creationId xmlns:a16="http://schemas.microsoft.com/office/drawing/2014/main" id="{3E47D19C-5825-40C9-8A5A-A5957E45A7F6}"/>
+                <a16:creationId xmlns:a16="http://schemas.microsoft.com/office/drawing/2014/main" id="{95384DC6-9DE7-4BF5-9463-791F40FC4CFD}"/>
               </a:ext>
             </a:extLst>
           </p:cNvPr>
@@ -2779,8 +2836,8 @@
         </p:nvSpPr>
         <p:spPr>
           <a:xfrm xmlns:a="http://schemas.openxmlformats.org/drawingml/2006/main">
-            <a:off x="742950" y="4314825"/>
-            <a:ext cx="9667875" cy="428625"/>
+            <a:off x="7077075" y="3867150"/>
+            <a:ext cx="4191000" cy="781050"/>
           </a:xfrm>
           <a:prstGeom xmlns:a="http://schemas.openxmlformats.org/drawingml/2006/main" prst="rect">
             <a:avLst/>
@@ -2797,35 +2854,35 @@
           <a:lstStyle xmlns:a="http://schemas.openxmlformats.org/drawingml/2006/main"/>
           <a:p xmlns:a="http://schemas.openxmlformats.org/drawingml/2006/main">
             <a:pPr>
-              <a:defRPr sz="2400" b="1">
-                <a:solidFill>
-                  <a:srgbClr val="F8F9F5"/>
-                </a:solidFill>
-                <a:latin typeface="DM Sans"/>
-                <a:ea typeface="DM Sans"/>
-                <a:cs typeface="DM Sans"/>
-              </a:defRPr>
-            </a:pPr>
-            <a:r>
-              <a:rPr sz="2400" b="1">
-                <a:solidFill>
-                  <a:srgbClr val="F8F9F5"/>
-                </a:solidFill>
-                <a:latin typeface="DM Sans"/>
-                <a:ea typeface="DM Sans"/>
-                <a:cs typeface="DM Sans"/>
-              </a:rPr>
-              <a:t>28 Aug–15 Sep 2026 UTC</a:t>
-            </a:r>
-          </a:p>
-        </p:txBody>
-      </p:sp>
-      <p:sp>
-        <p:nvSpPr>
-          <p:cNvPr id="7" name="A 144-hour gap remains missing.&#10;Historical re">
+              <a:defRPr sz="4800" b="1">
+                <a:solidFill>
+                  <a:srgbClr val="D0A650"/>
+                </a:solidFill>
+                <a:latin typeface="Manrope"/>
+                <a:ea typeface="Manrope"/>
+                <a:cs typeface="Manrope"/>
+              </a:defRPr>
+            </a:pPr>
+            <a:r>
+              <a:rPr sz="4800" b="1">
+                <a:solidFill>
+                  <a:srgbClr val="D0A650"/>
+                </a:solidFill>
+                <a:latin typeface="Manrope"/>
+                <a:ea typeface="Manrope"/>
+                <a:cs typeface="Manrope"/>
+              </a:rPr>
+              <a:t>0 kg</a:t>
+            </a:r>
+          </a:p>
+        </p:txBody>
+      </p:sp>
+      <p:sp>
+        <p:nvSpPr>
+          <p:cNvPr id="7" name="Humid day or missing evidence">
             <a:extLst xmlns:a="http://schemas.openxmlformats.org/drawingml/2006/main">
               <a:ext uri="{FF2B5EF4-FFF2-40B4-BE49-F238E27FC236}">
-                <a16:creationId xmlns:a16="http://schemas.microsoft.com/office/drawing/2014/main" id="{2CCF9CC5-3CB8-4B05-8C36-302E4DED4B83}"/>
+                <a16:creationId xmlns:a16="http://schemas.microsoft.com/office/drawing/2014/main" id="{BBE52EF8-E80B-4B94-B926-3F77BF1C66A9}"/>
               </a:ext>
             </a:extLst>
           </p:cNvPr>
@@ -2836,8 +2893,8 @@
         </p:nvSpPr>
         <p:spPr>
           <a:xfrm xmlns:a="http://schemas.openxmlformats.org/drawingml/2006/main">
-            <a:off x="742950" y="4962525"/>
-            <a:ext cx="10382250" cy="819150"/>
+            <a:off x="7115175" y="4752975"/>
+            <a:ext cx="4286250" cy="685800"/>
           </a:xfrm>
           <a:prstGeom xmlns:a="http://schemas.openxmlformats.org/drawingml/2006/main" prst="rect">
             <a:avLst/>
@@ -2854,7 +2911,7 @@
           <a:lstStyle xmlns:a="http://schemas.openxmlformats.org/drawingml/2006/main"/>
           <a:p xmlns:a="http://schemas.openxmlformats.org/drawingml/2006/main">
             <a:pPr>
-              <a:defRPr sz="2175" b="0">
+              <a:defRPr sz="1950" b="0">
                 <a:solidFill>
                   <a:srgbClr val="DEE5D9"/>
                 </a:solidFill>
@@ -2864,7 +2921,7 @@
               </a:defRPr>
             </a:pPr>
             <a:r>
-              <a:rPr sz="2175" b="0">
+              <a:rPr sz="1950" b="0">
                 <a:solidFill>
                   <a:srgbClr val="DEE5D9"/>
                 </a:solidFill>
@@ -2872,40 +2929,17 @@
                 <a:ea typeface="DM Sans"/>
                 <a:cs typeface="DM Sans"/>
               </a:rPr>
-              <a:t>A 144-hour gap remains missing.</a:t>
-            </a:r>
-          </a:p>
-          <a:p xmlns:a="http://schemas.openxmlformats.org/drawingml/2006/main">
-            <a:pPr>
-              <a:defRPr sz="2175" b="0">
-                <a:solidFill>
-                  <a:srgbClr val="DEE5D9"/>
-                </a:solidFill>
-                <a:latin typeface="DM Sans"/>
-                <a:ea typeface="DM Sans"/>
-                <a:cs typeface="DM Sans"/>
-              </a:defRPr>
-            </a:pPr>
-            <a:r>
-              <a:rPr sz="2175" b="0">
-                <a:solidFill>
-                  <a:srgbClr val="DEE5D9"/>
-                </a:solidFill>
-                <a:latin typeface="DM Sans"/>
-                <a:ea typeface="DM Sans"/>
-                <a:cs typeface="DM Sans"/>
-              </a:rPr>
-              <a:t>Historical replay represents one JKUAT station.</a:t>
-            </a:r>
-          </a:p>
-        </p:txBody>
-      </p:sp>
-      <p:sp>
-        <p:nvSpPr>
-          <p:cNvPr id="8" name="Kavu    03">
+              <a:t>Humid day or missing evidence</a:t>
+            </a:r>
+          </a:p>
+        </p:txBody>
+      </p:sp>
+      <p:sp>
+        <p:nvSpPr>
+          <p:cNvPr id="8" name="Same example lots, deadlines and capacity. Re">
             <a:extLst xmlns:a="http://schemas.openxmlformats.org/drawingml/2006/main">
               <a:ext uri="{FF2B5EF4-FFF2-40B4-BE49-F238E27FC236}">
-                <a16:creationId xmlns:a16="http://schemas.microsoft.com/office/drawing/2014/main" id="{A8D0CE2F-3116-43EF-A57F-F4684D3BCB56}"/>
+                <a16:creationId xmlns:a16="http://schemas.microsoft.com/office/drawing/2014/main" id="{797F3260-B5BC-4A1A-BDB5-CD259057A59D}"/>
               </a:ext>
             </a:extLst>
           </p:cNvPr>
@@ -2916,8 +2950,8 @@
         </p:nvSpPr>
         <p:spPr>
           <a:xfrm xmlns:a="http://schemas.openxmlformats.org/drawingml/2006/main">
-            <a:off x="685800" y="6334125"/>
-            <a:ext cx="10668000" cy="228600"/>
+            <a:off x="762000" y="5686425"/>
+            <a:ext cx="10287000" cy="381000"/>
           </a:xfrm>
           <a:prstGeom xmlns:a="http://schemas.openxmlformats.org/drawingml/2006/main" prst="rect">
             <a:avLst/>
@@ -2934,6 +2968,63 @@
           <a:lstStyle xmlns:a="http://schemas.openxmlformats.org/drawingml/2006/main"/>
           <a:p xmlns:a="http://schemas.openxmlformats.org/drawingml/2006/main">
             <a:pPr>
+              <a:defRPr sz="1800" b="0">
+                <a:solidFill>
+                  <a:srgbClr val="DEE5D9"/>
+                </a:solidFill>
+                <a:latin typeface="DM Sans"/>
+                <a:ea typeface="DM Sans"/>
+                <a:cs typeface="DM Sans"/>
+              </a:defRPr>
+            </a:pPr>
+            <a:r>
+              <a:rPr sz="1800" b="0">
+                <a:solidFill>
+                  <a:srgbClr val="DEE5D9"/>
+                </a:solidFill>
+                <a:latin typeface="DM Sans"/>
+                <a:ea typeface="DM Sans"/>
+                <a:cs typeface="DM Sans"/>
+              </a:rPr>
+              <a:t>Same example lots, deadlines and capacity. Retrospective comparison.</a:t>
+            </a:r>
+          </a:p>
+        </p:txBody>
+      </p:sp>
+      <p:sp>
+        <p:nvSpPr>
+          <p:cNvPr id="9" name="Kavu    03">
+            <a:extLst xmlns:a="http://schemas.openxmlformats.org/drawingml/2006/main">
+              <a:ext uri="{FF2B5EF4-FFF2-40B4-BE49-F238E27FC236}">
+                <a16:creationId xmlns:a16="http://schemas.microsoft.com/office/drawing/2014/main" id="{28519EBF-E7E8-4378-A024-4CE56A80D209}"/>
+              </a:ext>
+            </a:extLst>
+          </p:cNvPr>
+          <p:cNvSpPr>
+            <a:spLocks xmlns:a="http://schemas.openxmlformats.org/drawingml/2006/main" noGrp="1"/>
+          </p:cNvSpPr>
+          <p:nvPr/>
+        </p:nvSpPr>
+        <p:spPr>
+          <a:xfrm xmlns:a="http://schemas.openxmlformats.org/drawingml/2006/main">
+            <a:off x="685800" y="6334125"/>
+            <a:ext cx="10668000" cy="228600"/>
+          </a:xfrm>
+          <a:prstGeom xmlns:a="http://schemas.openxmlformats.org/drawingml/2006/main" prst="rect">
+            <a:avLst/>
+          </a:prstGeom>
+          <a:noFill xmlns:a="http://schemas.openxmlformats.org/drawingml/2006/main"/>
+          <a:ln xmlns:a="http://schemas.openxmlformats.org/drawingml/2006/main" w="0">
+            <a:noFill/>
+          </a:ln>
+        </p:spPr>
+        <p:txBody>
+          <a:bodyPr xmlns:a="http://schemas.openxmlformats.org/drawingml/2006/main" wrap="square" lIns="0" tIns="0" rIns="0" bIns="0">
+            <a:noAutofit/>
+          </a:bodyPr>
+          <a:lstStyle xmlns:a="http://schemas.openxmlformats.org/drawingml/2006/main"/>
+          <a:p xmlns:a="http://schemas.openxmlformats.org/drawingml/2006/main">
+            <a:pPr>
               <a:defRPr sz="1200" b="0">
                 <a:solidFill>
                   <a:srgbClr val="DEE5D9"/>
@@ -2960,7 +3051,7 @@
     </p:spTree>
     <p:extLst>
       <p:ext uri="{BB962C8B-B14F-4D97-AF65-F5344CB8AC3E}">
-        <p14:creationId xmlns:p14="http://schemas.microsoft.com/office/powerpoint/2010/main" val="1283748357"/>
+        <p14:creationId xmlns:p14="http://schemas.microsoft.com/office/powerpoint/2010/main" val="120248981"/>
       </p:ext>
     </p:extLst>
   </p:cSld>
@@ -2991,7 +3082,7 @@
           <p:cNvPr id="6" name="One workspace for the next job">
             <a:extLst xmlns:a="http://schemas.openxmlformats.org/drawingml/2006/main">
               <a:ext uri="{FF2B5EF4-FFF2-40B4-BE49-F238E27FC236}">
-                <a16:creationId xmlns:a16="http://schemas.microsoft.com/office/drawing/2014/main" id="{9152C43B-BA1C-492B-B7B9-40681FAA9401}"/>
+                <a16:creationId xmlns:a16="http://schemas.microsoft.com/office/drawing/2014/main" id="{7618612E-EC73-4258-99F3-2CE220688603}"/>
               </a:ext>
             </a:extLst>
           </p:cNvPr>
@@ -3048,7 +3139,7 @@
           <p:cNvPr id="2" name="A plan the&#10;operator can&#10;carry out">
             <a:extLst xmlns:a="http://schemas.openxmlformats.org/drawingml/2006/main">
               <a:ext uri="{FF2B5EF4-FFF2-40B4-BE49-F238E27FC236}">
-                <a16:creationId xmlns:a16="http://schemas.microsoft.com/office/drawing/2014/main" id="{61F19BC3-B77D-4088-8756-1DB605AF84CD}"/>
+                <a16:creationId xmlns:a16="http://schemas.microsoft.com/office/drawing/2014/main" id="{D95D93F0-0776-4E2A-8AC4-0466F102C0F2}"/>
               </a:ext>
             </a:extLst>
           </p:cNvPr>
@@ -3151,7 +3242,7 @@
           <p:cNvPr id="3" name="Capacity-aware allocation&#10;&#10;Recorded task comp">
             <a:extLst xmlns:a="http://schemas.openxmlformats.org/drawingml/2006/main">
               <a:ext uri="{FF2B5EF4-FFF2-40B4-BE49-F238E27FC236}">
-                <a16:creationId xmlns:a16="http://schemas.microsoft.com/office/drawing/2014/main" id="{294A2DAF-B8AD-4AFE-B160-01040ED73B39}"/>
+                <a16:creationId xmlns:a16="http://schemas.microsoft.com/office/drawing/2014/main" id="{0A47003D-FA15-4613-9759-5BF2F9D273BD}"/>
               </a:ext>
             </a:extLst>
           </p:cNvPr>
@@ -3268,13 +3359,13 @@
           <p:nvPr/>
         </p:nvPicPr>
         <p:blipFill>
-          <a:blip xmlns:r="http://schemas.openxmlformats.org/officeDocument/2006/relationships" xmlns:a="http://schemas.openxmlformats.org/drawingml/2006/main" r:embed="Rfcea5ddde08a4ccb"/>
+          <a:blip xmlns:r="http://schemas.openxmlformats.org/officeDocument/2006/relationships" xmlns:a="http://schemas.openxmlformats.org/drawingml/2006/main" r:embed="R8a6bd4872bd8438f"/>
           <a:stretch xmlns:a="http://schemas.openxmlformats.org/drawingml/2006/main"/>
         </p:blipFill>
         <p:spPr>
           <a:xfrm xmlns:a="http://schemas.openxmlformats.org/drawingml/2006/main">
-            <a:off x="4590252" y="1533525"/>
-            <a:ext cx="6707196" cy="4448175"/>
+            <a:off x="5045492" y="1533525"/>
+            <a:ext cx="5796717" cy="4448175"/>
           </a:xfrm>
           <a:prstGeom xmlns:a="http://schemas.openxmlformats.org/drawingml/2006/main" prst="rect">
             <a:avLst/>
@@ -3286,7 +3377,7 @@
           <p:cNvPr id="5" name="Kavu    04">
             <a:extLst xmlns:a="http://schemas.openxmlformats.org/drawingml/2006/main">
               <a:ext uri="{FF2B5EF4-FFF2-40B4-BE49-F238E27FC236}">
-                <a16:creationId xmlns:a16="http://schemas.microsoft.com/office/drawing/2014/main" id="{7FBCCF95-D192-4C9E-86F1-D0C73F58EEBE}"/>
+                <a16:creationId xmlns:a16="http://schemas.microsoft.com/office/drawing/2014/main" id="{C50FD256-E2EB-4274-BE87-C96ABB6676A4}"/>
               </a:ext>
             </a:extLst>
           </p:cNvPr>
@@ -3341,7 +3432,7 @@
     </p:spTree>
     <p:extLst>
       <p:ext uri="{BB962C8B-B14F-4D97-AF65-F5344CB8AC3E}">
-        <p14:creationId xmlns:p14="http://schemas.microsoft.com/office/powerpoint/2010/main" val="581916715"/>
+        <p14:creationId xmlns:p14="http://schemas.microsoft.com/office/powerpoint/2010/main" val="908835561"/>
       </p:ext>
     </p:extLst>
   </p:cSld>
@@ -3369,10 +3460,10 @@
       </p:grpSpPr>
       <p:sp>
         <p:nvSpPr>
-          <p:cNvPr id="16" name="A measurement closes each decision">
+          <p:cNvPr id="11" name="Private accounts and cloud records">
             <a:extLst xmlns:a="http://schemas.openxmlformats.org/drawingml/2006/main">
               <a:ext uri="{FF2B5EF4-FFF2-40B4-BE49-F238E27FC236}">
-                <a16:creationId xmlns:a16="http://schemas.microsoft.com/office/drawing/2014/main" id="{57B825D5-D668-4D84-8D85-95F16D7ABBC3}"/>
+                <a16:creationId xmlns:a16="http://schemas.microsoft.com/office/drawing/2014/main" id="{2466E6B7-928E-42FE-851A-3223CFDCDAE6}"/>
               </a:ext>
             </a:extLst>
           </p:cNvPr>
@@ -3419,17 +3510,17 @@
                 <a:ea typeface="Manrope"/>
                 <a:cs typeface="Manrope"/>
               </a:rPr>
-              <a:t>A measurement closes each decision</a:t>
-            </a:r>
-          </a:p>
-        </p:txBody>
-      </p:sp>
-      <p:sp>
-        <p:nvSpPr>
-          <p:cNvPr id="2" name="01">
+              <a:t>Private accounts and cloud records</a:t>
+            </a:r>
+          </a:p>
+        </p:txBody>
+      </p:sp>
+      <p:sp>
+        <p:nvSpPr>
+          <p:cNvPr id="2" name="Hosted application">
             <a:extLst xmlns:a="http://schemas.openxmlformats.org/drawingml/2006/main">
               <a:ext uri="{FF2B5EF4-FFF2-40B4-BE49-F238E27FC236}">
-                <a16:creationId xmlns:a16="http://schemas.microsoft.com/office/drawing/2014/main" id="{156F3AC1-2047-4C07-AD96-8C64D92B2CA4}"/>
+                <a16:creationId xmlns:a16="http://schemas.microsoft.com/office/drawing/2014/main" id="{22D8F6D8-F084-4465-AD43-357DDD45A7F9}"/>
               </a:ext>
             </a:extLst>
           </p:cNvPr>
@@ -3440,8 +3531,8 @@
         </p:nvSpPr>
         <p:spPr>
           <a:xfrm xmlns:a="http://schemas.openxmlformats.org/drawingml/2006/main">
-            <a:off x="685800" y="2038350"/>
-            <a:ext cx="2381250" cy="619125"/>
+            <a:off x="704850" y="1971675"/>
+            <a:ext cx="6572250" cy="504825"/>
           </a:xfrm>
           <a:prstGeom xmlns:a="http://schemas.openxmlformats.org/drawingml/2006/main" prst="rect">
             <a:avLst/>
@@ -3458,9 +3549,9 @@
           <a:lstStyle xmlns:a="http://schemas.openxmlformats.org/drawingml/2006/main"/>
           <a:p xmlns:a="http://schemas.openxmlformats.org/drawingml/2006/main">
             <a:pPr>
-              <a:defRPr sz="4050" b="1">
-                <a:solidFill>
-                  <a:srgbClr val="D0A650"/>
+              <a:defRPr sz="2700" b="1">
+                <a:solidFill>
+                  <a:srgbClr val="244D37"/>
                 </a:solidFill>
                 <a:latin typeface="Manrope"/>
                 <a:ea typeface="Manrope"/>
@@ -3468,25 +3559,25 @@
               </a:defRPr>
             </a:pPr>
             <a:r>
-              <a:rPr sz="4050" b="1">
-                <a:solidFill>
-                  <a:srgbClr val="D0A650"/>
+              <a:rPr sz="2700" b="1">
+                <a:solidFill>
+                  <a:srgbClr val="244D37"/>
                 </a:solidFill>
                 <a:latin typeface="Manrope"/>
                 <a:ea typeface="Manrope"/>
                 <a:cs typeface="Manrope"/>
               </a:rPr>
-              <a:t>01</a:t>
-            </a:r>
-          </a:p>
-        </p:txBody>
-      </p:sp>
-      <p:sp>
-        <p:nvSpPr>
-          <p:cNvPr id="3" name="Record the lot">
+              <a:t>Hosted application</a:t>
+            </a:r>
+          </a:p>
+        </p:txBody>
+      </p:sp>
+      <p:sp>
+        <p:nvSpPr>
+          <p:cNvPr id="3" name="Firebase Hosting">
             <a:extLst xmlns:a="http://schemas.openxmlformats.org/drawingml/2006/main">
               <a:ext uri="{FF2B5EF4-FFF2-40B4-BE49-F238E27FC236}">
-                <a16:creationId xmlns:a16="http://schemas.microsoft.com/office/drawing/2014/main" id="{3BCB911B-FEDD-4CFF-930E-21FF21F9312A}"/>
+                <a16:creationId xmlns:a16="http://schemas.microsoft.com/office/drawing/2014/main" id="{5E856032-82D7-4634-AA94-7DB9D592BC2A}"/>
               </a:ext>
             </a:extLst>
           </p:cNvPr>
@@ -3497,8 +3588,8 @@
         </p:nvSpPr>
         <p:spPr>
           <a:xfrm xmlns:a="http://schemas.openxmlformats.org/drawingml/2006/main">
-            <a:off x="685800" y="2981325"/>
-            <a:ext cx="2476500" cy="781050"/>
+            <a:off x="742950" y="2800350"/>
+            <a:ext cx="5905500" cy="495300"/>
           </a:xfrm>
           <a:prstGeom xmlns:a="http://schemas.openxmlformats.org/drawingml/2006/main" prst="rect">
             <a:avLst/>
@@ -3533,17 +3624,17 @@
                 <a:ea typeface="DM Sans"/>
                 <a:cs typeface="DM Sans"/>
               </a:rPr>
-              <a:t>Record the lot</a:t>
-            </a:r>
-          </a:p>
-        </p:txBody>
-      </p:sp>
-      <p:sp>
-        <p:nvSpPr>
-          <p:cNvPr id="4" name="Mass, measured moisture&#10;and a configured targ">
+              <a:t>Firebase Hosting</a:t>
+            </a:r>
+          </a:p>
+        </p:txBody>
+      </p:sp>
+      <p:sp>
+        <p:nvSpPr>
+          <p:cNvPr id="4" name="React and TypeScript interface">
             <a:extLst xmlns:a="http://schemas.openxmlformats.org/drawingml/2006/main">
               <a:ext uri="{FF2B5EF4-FFF2-40B4-BE49-F238E27FC236}">
-                <a16:creationId xmlns:a16="http://schemas.microsoft.com/office/drawing/2014/main" id="{459393FD-0132-40FE-8A0C-9EE5E766359E}"/>
+                <a16:creationId xmlns:a16="http://schemas.microsoft.com/office/drawing/2014/main" id="{C7DC88A0-85B0-4488-826B-30D311E51404}"/>
               </a:ext>
             </a:extLst>
           </p:cNvPr>
@@ -3554,8 +3645,8 @@
         </p:nvSpPr>
         <p:spPr>
           <a:xfrm xmlns:a="http://schemas.openxmlformats.org/drawingml/2006/main">
-            <a:off x="685800" y="3933825"/>
-            <a:ext cx="2409825" cy="1047750"/>
+            <a:off x="742950" y="3286125"/>
+            <a:ext cx="5905500" cy="409575"/>
           </a:xfrm>
           <a:prstGeom xmlns:a="http://schemas.openxmlformats.org/drawingml/2006/main" prst="rect">
             <a:avLst/>
@@ -3572,7 +3663,7 @@
           <a:lstStyle xmlns:a="http://schemas.openxmlformats.org/drawingml/2006/main"/>
           <a:p xmlns:a="http://schemas.openxmlformats.org/drawingml/2006/main">
             <a:pPr>
-              <a:defRPr sz="1875" b="0">
+              <a:defRPr sz="1950" b="0">
                 <a:solidFill>
                   <a:srgbClr val="667561"/>
                 </a:solidFill>
@@ -3582,7 +3673,7 @@
               </a:defRPr>
             </a:pPr>
             <a:r>
-              <a:rPr sz="1875" b="0">
+              <a:rPr sz="1950" b="0">
                 <a:solidFill>
                   <a:srgbClr val="667561"/>
                 </a:solidFill>
@@ -3590,40 +3681,17 @@
                 <a:ea typeface="DM Sans"/>
                 <a:cs typeface="DM Sans"/>
               </a:rPr>
-              <a:t>Mass, measured moisture</a:t>
-            </a:r>
-          </a:p>
-          <a:p xmlns:a="http://schemas.openxmlformats.org/drawingml/2006/main">
-            <a:pPr>
-              <a:defRPr sz="1875" b="0">
-                <a:solidFill>
-                  <a:srgbClr val="667561"/>
-                </a:solidFill>
-                <a:latin typeface="DM Sans"/>
-                <a:ea typeface="DM Sans"/>
-                <a:cs typeface="DM Sans"/>
-              </a:defRPr>
-            </a:pPr>
-            <a:r>
-              <a:rPr sz="1875" b="0">
-                <a:solidFill>
-                  <a:srgbClr val="667561"/>
-                </a:solidFill>
-                <a:latin typeface="DM Sans"/>
-                <a:ea typeface="DM Sans"/>
-                <a:cs typeface="DM Sans"/>
-              </a:rPr>
-              <a:t>and a configured target.</a:t>
-            </a:r>
-          </a:p>
-        </p:txBody>
-      </p:sp>
-      <p:sp>
-        <p:nvSpPr>
-          <p:cNvPr id="5" name="02">
+              <a:t>React and TypeScript interface</a:t>
+            </a:r>
+          </a:p>
+        </p:txBody>
+      </p:sp>
+      <p:sp>
+        <p:nvSpPr>
+          <p:cNvPr id="5" name="Cloud Run API with Firestore">
             <a:extLst xmlns:a="http://schemas.openxmlformats.org/drawingml/2006/main">
               <a:ext uri="{FF2B5EF4-FFF2-40B4-BE49-F238E27FC236}">
-                <a16:creationId xmlns:a16="http://schemas.microsoft.com/office/drawing/2014/main" id="{EE7F38EA-6ACA-4C41-A206-F91E307B38F7}"/>
+                <a16:creationId xmlns:a16="http://schemas.microsoft.com/office/drawing/2014/main" id="{325C8102-5300-4874-BB55-D9E95C50D4EB}"/>
               </a:ext>
             </a:extLst>
           </p:cNvPr>
@@ -3634,8 +3702,8 @@
         </p:nvSpPr>
         <p:spPr>
           <a:xfrm xmlns:a="http://schemas.openxmlformats.org/drawingml/2006/main">
-            <a:off x="3495675" y="2038350"/>
-            <a:ext cx="2381250" cy="619125"/>
+            <a:off x="742950" y="4057650"/>
+            <a:ext cx="6096000" cy="523875"/>
           </a:xfrm>
           <a:prstGeom xmlns:a="http://schemas.openxmlformats.org/drawingml/2006/main" prst="rect">
             <a:avLst/>
@@ -3652,35 +3720,35 @@
           <a:lstStyle xmlns:a="http://schemas.openxmlformats.org/drawingml/2006/main"/>
           <a:p xmlns:a="http://schemas.openxmlformats.org/drawingml/2006/main">
             <a:pPr>
-              <a:defRPr sz="4050" b="1">
-                <a:solidFill>
-                  <a:srgbClr val="D0A650"/>
-                </a:solidFill>
-                <a:latin typeface="Manrope"/>
-                <a:ea typeface="Manrope"/>
-                <a:cs typeface="Manrope"/>
-              </a:defRPr>
-            </a:pPr>
-            <a:r>
-              <a:rPr sz="4050" b="1">
-                <a:solidFill>
-                  <a:srgbClr val="D0A650"/>
-                </a:solidFill>
-                <a:latin typeface="Manrope"/>
-                <a:ea typeface="Manrope"/>
-                <a:cs typeface="Manrope"/>
-              </a:rPr>
-              <a:t>02</a:t>
-            </a:r>
-          </a:p>
-        </p:txBody>
-      </p:sp>
-      <p:sp>
-        <p:nvSpPr>
-          <p:cNvPr id="6" name="Assign the work">
+              <a:defRPr sz="2325" b="1">
+                <a:solidFill>
+                  <a:srgbClr val="244D37"/>
+                </a:solidFill>
+                <a:latin typeface="DM Sans"/>
+                <a:ea typeface="DM Sans"/>
+                <a:cs typeface="DM Sans"/>
+              </a:defRPr>
+            </a:pPr>
+            <a:r>
+              <a:rPr sz="2325" b="1">
+                <a:solidFill>
+                  <a:srgbClr val="244D37"/>
+                </a:solidFill>
+                <a:latin typeface="DM Sans"/>
+                <a:ea typeface="DM Sans"/>
+                <a:cs typeface="DM Sans"/>
+              </a:rPr>
+              <a:t>Cloud Run API with Firestore</a:t>
+            </a:r>
+          </a:p>
+        </p:txBody>
+      </p:sp>
+      <p:sp>
+        <p:nvSpPr>
+          <p:cNvPr id="6" name="Private accounts and persistent lot records">
             <a:extLst xmlns:a="http://schemas.openxmlformats.org/drawingml/2006/main">
               <a:ext uri="{FF2B5EF4-FFF2-40B4-BE49-F238E27FC236}">
-                <a16:creationId xmlns:a16="http://schemas.microsoft.com/office/drawing/2014/main" id="{A8422A25-B357-4826-B4B6-11A05C42160C}"/>
+                <a16:creationId xmlns:a16="http://schemas.microsoft.com/office/drawing/2014/main" id="{B7B1A7BC-71B8-4122-B7EF-28AAD28D966C}"/>
               </a:ext>
             </a:extLst>
           </p:cNvPr>
@@ -3691,8 +3759,8 @@
         </p:nvSpPr>
         <p:spPr>
           <a:xfrm xmlns:a="http://schemas.openxmlformats.org/drawingml/2006/main">
-            <a:off x="3495675" y="2981325"/>
-            <a:ext cx="2476500" cy="781050"/>
+            <a:off x="742950" y="4562475"/>
+            <a:ext cx="6000750" cy="714375"/>
           </a:xfrm>
           <a:prstGeom xmlns:a="http://schemas.openxmlformats.org/drawingml/2006/main" prst="rect">
             <a:avLst/>
@@ -3709,35 +3777,35 @@
           <a:lstStyle xmlns:a="http://schemas.openxmlformats.org/drawingml/2006/main"/>
           <a:p xmlns:a="http://schemas.openxmlformats.org/drawingml/2006/main">
             <a:pPr>
-              <a:defRPr sz="2325" b="1">
-                <a:solidFill>
-                  <a:srgbClr val="244D37"/>
-                </a:solidFill>
-                <a:latin typeface="DM Sans"/>
-                <a:ea typeface="DM Sans"/>
-                <a:cs typeface="DM Sans"/>
-              </a:defRPr>
-            </a:pPr>
-            <a:r>
-              <a:rPr sz="2325" b="1">
-                <a:solidFill>
-                  <a:srgbClr val="244D37"/>
-                </a:solidFill>
-                <a:latin typeface="DM Sans"/>
-                <a:ea typeface="DM Sans"/>
-                <a:cs typeface="DM Sans"/>
-              </a:rPr>
-              <a:t>Assign the work</a:t>
-            </a:r>
-          </a:p>
-        </p:txBody>
-      </p:sp>
-      <p:sp>
-        <p:nvSpPr>
-          <p:cNvPr id="7" name="Environmental evidence&#10;and available capacity">
+              <a:defRPr sz="1950" b="0">
+                <a:solidFill>
+                  <a:srgbClr val="667561"/>
+                </a:solidFill>
+                <a:latin typeface="DM Sans"/>
+                <a:ea typeface="DM Sans"/>
+                <a:cs typeface="DM Sans"/>
+              </a:defRPr>
+            </a:pPr>
+            <a:r>
+              <a:rPr sz="1950" b="0">
+                <a:solidFill>
+                  <a:srgbClr val="667561"/>
+                </a:solidFill>
+                <a:latin typeface="DM Sans"/>
+                <a:ea typeface="DM Sans"/>
+                <a:cs typeface="DM Sans"/>
+              </a:rPr>
+              <a:t>Private accounts and persistent lot records</a:t>
+            </a:r>
+          </a:p>
+        </p:txBody>
+      </p:sp>
+      <p:sp>
+        <p:nvSpPr>
+          <p:cNvPr id="7" name="Self-hosting">
             <a:extLst xmlns:a="http://schemas.openxmlformats.org/drawingml/2006/main">
               <a:ext uri="{FF2B5EF4-FFF2-40B4-BE49-F238E27FC236}">
-                <a16:creationId xmlns:a16="http://schemas.microsoft.com/office/drawing/2014/main" id="{C82FCBEA-1B83-4CDD-9254-17090F1EEB63}"/>
+                <a16:creationId xmlns:a16="http://schemas.microsoft.com/office/drawing/2014/main" id="{2D915213-E162-4052-BD69-4C2084AD6018}"/>
               </a:ext>
             </a:extLst>
           </p:cNvPr>
@@ -3748,8 +3816,8 @@
         </p:nvSpPr>
         <p:spPr>
           <a:xfrm xmlns:a="http://schemas.openxmlformats.org/drawingml/2006/main">
-            <a:off x="3495675" y="3933825"/>
-            <a:ext cx="2409825" cy="1047750"/>
+            <a:off x="7943850" y="2009775"/>
+            <a:ext cx="3619500" cy="476250"/>
           </a:xfrm>
           <a:prstGeom xmlns:a="http://schemas.openxmlformats.org/drawingml/2006/main" prst="rect">
             <a:avLst/>
@@ -3766,58 +3834,35 @@
           <a:lstStyle xmlns:a="http://schemas.openxmlformats.org/drawingml/2006/main"/>
           <a:p xmlns:a="http://schemas.openxmlformats.org/drawingml/2006/main">
             <a:pPr>
-              <a:defRPr sz="1875" b="0">
-                <a:solidFill>
-                  <a:srgbClr val="667561"/>
-                </a:solidFill>
-                <a:latin typeface="DM Sans"/>
-                <a:ea typeface="DM Sans"/>
-                <a:cs typeface="DM Sans"/>
-              </a:defRPr>
-            </a:pPr>
-            <a:r>
-              <a:rPr sz="1875" b="0">
-                <a:solidFill>
-                  <a:srgbClr val="667561"/>
-                </a:solidFill>
-                <a:latin typeface="DM Sans"/>
-                <a:ea typeface="DM Sans"/>
-                <a:cs typeface="DM Sans"/>
-              </a:rPr>
-              <a:t>Environmental evidence</a:t>
-            </a:r>
-          </a:p>
-          <a:p xmlns:a="http://schemas.openxmlformats.org/drawingml/2006/main">
-            <a:pPr>
-              <a:defRPr sz="1875" b="0">
-                <a:solidFill>
-                  <a:srgbClr val="667561"/>
-                </a:solidFill>
-                <a:latin typeface="DM Sans"/>
-                <a:ea typeface="DM Sans"/>
-                <a:cs typeface="DM Sans"/>
-              </a:defRPr>
-            </a:pPr>
-            <a:r>
-              <a:rPr sz="1875" b="0">
-                <a:solidFill>
-                  <a:srgbClr val="667561"/>
-                </a:solidFill>
-                <a:latin typeface="DM Sans"/>
-                <a:ea typeface="DM Sans"/>
-                <a:cs typeface="DM Sans"/>
-              </a:rPr>
-              <a:t>and available capacity.</a:t>
-            </a:r>
-          </a:p>
-        </p:txBody>
-      </p:sp>
-      <p:sp>
-        <p:nvSpPr>
-          <p:cNvPr id="8" name="03">
+              <a:defRPr sz="2550" b="1">
+                <a:solidFill>
+                  <a:srgbClr val="244D37"/>
+                </a:solidFill>
+                <a:latin typeface="Manrope"/>
+                <a:ea typeface="Manrope"/>
+                <a:cs typeface="Manrope"/>
+              </a:defRPr>
+            </a:pPr>
+            <a:r>
+              <a:rPr sz="2550" b="1">
+                <a:solidFill>
+                  <a:srgbClr val="244D37"/>
+                </a:solidFill>
+                <a:latin typeface="Manrope"/>
+                <a:ea typeface="Manrope"/>
+                <a:cs typeface="Manrope"/>
+              </a:rPr>
+              <a:t>Self-hosting</a:t>
+            </a:r>
+          </a:p>
+        </p:txBody>
+      </p:sp>
+      <p:sp>
+        <p:nvSpPr>
+          <p:cNvPr id="8" name="Express and SQLite&#10;Docker deployment&#10;Shared d">
             <a:extLst xmlns:a="http://schemas.openxmlformats.org/drawingml/2006/main">
               <a:ext uri="{FF2B5EF4-FFF2-40B4-BE49-F238E27FC236}">
-                <a16:creationId xmlns:a16="http://schemas.microsoft.com/office/drawing/2014/main" id="{F703B550-D5BA-4E8C-8CC1-CFB4DACBD51B}"/>
+                <a16:creationId xmlns:a16="http://schemas.microsoft.com/office/drawing/2014/main" id="{CA735001-68A7-4A95-9392-1EABF3A0A911}"/>
               </a:ext>
             </a:extLst>
           </p:cNvPr>
@@ -3828,8 +3873,8 @@
         </p:nvSpPr>
         <p:spPr>
           <a:xfrm xmlns:a="http://schemas.openxmlformats.org/drawingml/2006/main">
-            <a:off x="6305550" y="2038350"/>
-            <a:ext cx="2381250" cy="619125"/>
+            <a:off x="7981950" y="2952750"/>
+            <a:ext cx="3371850" cy="1819275"/>
           </a:xfrm>
           <a:prstGeom xmlns:a="http://schemas.openxmlformats.org/drawingml/2006/main" prst="rect">
             <a:avLst/>
@@ -3846,35 +3891,81 @@
           <a:lstStyle xmlns:a="http://schemas.openxmlformats.org/drawingml/2006/main"/>
           <a:p xmlns:a="http://schemas.openxmlformats.org/drawingml/2006/main">
             <a:pPr>
-              <a:defRPr sz="4050" b="1">
-                <a:solidFill>
-                  <a:srgbClr val="D0A650"/>
-                </a:solidFill>
-                <a:latin typeface="Manrope"/>
-                <a:ea typeface="Manrope"/>
-                <a:cs typeface="Manrope"/>
-              </a:defRPr>
-            </a:pPr>
-            <a:r>
-              <a:rPr sz="4050" b="1">
-                <a:solidFill>
-                  <a:srgbClr val="D0A650"/>
-                </a:solidFill>
-                <a:latin typeface="Manrope"/>
-                <a:ea typeface="Manrope"/>
-                <a:cs typeface="Manrope"/>
-              </a:rPr>
-              <a:t>03</a:t>
-            </a:r>
-          </a:p>
-        </p:txBody>
-      </p:sp>
-      <p:sp>
-        <p:nvSpPr>
-          <p:cNvPr id="9" name="Log a new reading">
+              <a:defRPr sz="2175" b="0">
+                <a:solidFill>
+                  <a:srgbClr val="667561"/>
+                </a:solidFill>
+                <a:latin typeface="DM Sans"/>
+                <a:ea typeface="DM Sans"/>
+                <a:cs typeface="DM Sans"/>
+              </a:defRPr>
+            </a:pPr>
+            <a:r>
+              <a:rPr sz="2175" b="0">
+                <a:solidFill>
+                  <a:srgbClr val="667561"/>
+                </a:solidFill>
+                <a:latin typeface="DM Sans"/>
+                <a:ea typeface="DM Sans"/>
+                <a:cs typeface="DM Sans"/>
+              </a:rPr>
+              <a:t>Express and SQLite</a:t>
+            </a:r>
+          </a:p>
+          <a:p xmlns:a="http://schemas.openxmlformats.org/drawingml/2006/main">
+            <a:pPr>
+              <a:defRPr sz="2175" b="0">
+                <a:solidFill>
+                  <a:srgbClr val="667561"/>
+                </a:solidFill>
+                <a:latin typeface="DM Sans"/>
+                <a:ea typeface="DM Sans"/>
+                <a:cs typeface="DM Sans"/>
+              </a:defRPr>
+            </a:pPr>
+            <a:r>
+              <a:rPr sz="2175" b="0">
+                <a:solidFill>
+                  <a:srgbClr val="667561"/>
+                </a:solidFill>
+                <a:latin typeface="DM Sans"/>
+                <a:ea typeface="DM Sans"/>
+                <a:cs typeface="DM Sans"/>
+              </a:rPr>
+              <a:t>Docker deployment</a:t>
+            </a:r>
+          </a:p>
+          <a:p xmlns:a="http://schemas.openxmlformats.org/drawingml/2006/main">
+            <a:pPr>
+              <a:defRPr sz="2175" b="0">
+                <a:solidFill>
+                  <a:srgbClr val="667561"/>
+                </a:solidFill>
+                <a:latin typeface="DM Sans"/>
+                <a:ea typeface="DM Sans"/>
+                <a:cs typeface="DM Sans"/>
+              </a:defRPr>
+            </a:pPr>
+            <a:r>
+              <a:rPr sz="2175" b="0">
+                <a:solidFill>
+                  <a:srgbClr val="667561"/>
+                </a:solidFill>
+                <a:latin typeface="DM Sans"/>
+                <a:ea typeface="DM Sans"/>
+                <a:cs typeface="DM Sans"/>
+              </a:rPr>
+              <a:t>Shared decision rules</a:t>
+            </a:r>
+          </a:p>
+        </p:txBody>
+      </p:sp>
+      <p:sp>
+        <p:nvSpPr>
+          <p:cNvPr id="9" name="kavu-drying.web.app">
             <a:extLst xmlns:a="http://schemas.openxmlformats.org/drawingml/2006/main">
               <a:ext uri="{FF2B5EF4-FFF2-40B4-BE49-F238E27FC236}">
-                <a16:creationId xmlns:a16="http://schemas.microsoft.com/office/drawing/2014/main" id="{A27FA791-DBAF-4D1E-81CD-243689E88E11}"/>
+                <a16:creationId xmlns:a16="http://schemas.microsoft.com/office/drawing/2014/main" id="{14417875-1077-4304-9F3C-261A08CAF840}"/>
               </a:ext>
             </a:extLst>
           </p:cNvPr>
@@ -3885,8 +3976,8 @@
         </p:nvSpPr>
         <p:spPr>
           <a:xfrm xmlns:a="http://schemas.openxmlformats.org/drawingml/2006/main">
-            <a:off x="6305550" y="2981325"/>
-            <a:ext cx="2476500" cy="781050"/>
+            <a:off x="752475" y="5724525"/>
+            <a:ext cx="10572750" cy="381000"/>
           </a:xfrm>
           <a:prstGeom xmlns:a="http://schemas.openxmlformats.org/drawingml/2006/main" prst="rect">
             <a:avLst/>
@@ -3903,7 +3994,7 @@
           <a:lstStyle xmlns:a="http://schemas.openxmlformats.org/drawingml/2006/main"/>
           <a:p xmlns:a="http://schemas.openxmlformats.org/drawingml/2006/main">
             <a:pPr>
-              <a:defRPr sz="2325" b="1">
+              <a:defRPr sz="1875" b="1">
                 <a:solidFill>
                   <a:srgbClr val="244D37"/>
                 </a:solidFill>
@@ -3913,7 +4004,7 @@
               </a:defRPr>
             </a:pPr>
             <a:r>
-              <a:rPr sz="2325" b="1">
+              <a:rPr sz="1875" b="1">
                 <a:solidFill>
                   <a:srgbClr val="244D37"/>
                 </a:solidFill>
@@ -3921,17 +4012,17 @@
                 <a:ea typeface="DM Sans"/>
                 <a:cs typeface="DM Sans"/>
               </a:rPr>
-              <a:t>Log a new reading</a:t>
-            </a:r>
-          </a:p>
-        </p:txBody>
-      </p:sp>
-      <p:sp>
-        <p:nvSpPr>
-          <p:cNvPr id="10" name="A person measures the grain&#10;after the handlin">
+              <a:t>kavu-drying.web.app</a:t>
+            </a:r>
+          </a:p>
+        </p:txBody>
+      </p:sp>
+      <p:sp>
+        <p:nvSpPr>
+          <p:cNvPr id="10" name="Kavu    05">
             <a:extLst xmlns:a="http://schemas.openxmlformats.org/drawingml/2006/main">
               <a:ext uri="{FF2B5EF4-FFF2-40B4-BE49-F238E27FC236}">
-                <a16:creationId xmlns:a16="http://schemas.microsoft.com/office/drawing/2014/main" id="{F5A43202-3AD7-4066-B868-4310CBB00A37}"/>
+                <a16:creationId xmlns:a16="http://schemas.microsoft.com/office/drawing/2014/main" id="{B1DDB554-393D-40A4-920D-710A9E82FF6F}"/>
               </a:ext>
             </a:extLst>
           </p:cNvPr>
@@ -3942,8 +4033,8 @@
         </p:nvSpPr>
         <p:spPr>
           <a:xfrm xmlns:a="http://schemas.openxmlformats.org/drawingml/2006/main">
-            <a:off x="6305550" y="3933825"/>
-            <a:ext cx="2409825" cy="1047750"/>
+            <a:off x="685800" y="6334125"/>
+            <a:ext cx="10668000" cy="228600"/>
           </a:xfrm>
           <a:prstGeom xmlns:a="http://schemas.openxmlformats.org/drawingml/2006/main" prst="rect">
             <a:avLst/>
@@ -3960,337 +4051,6 @@
           <a:lstStyle xmlns:a="http://schemas.openxmlformats.org/drawingml/2006/main"/>
           <a:p xmlns:a="http://schemas.openxmlformats.org/drawingml/2006/main">
             <a:pPr>
-              <a:defRPr sz="1875" b="0">
-                <a:solidFill>
-                  <a:srgbClr val="667561"/>
-                </a:solidFill>
-                <a:latin typeface="DM Sans"/>
-                <a:ea typeface="DM Sans"/>
-                <a:cs typeface="DM Sans"/>
-              </a:defRPr>
-            </a:pPr>
-            <a:r>
-              <a:rPr sz="1875" b="0">
-                <a:solidFill>
-                  <a:srgbClr val="667561"/>
-                </a:solidFill>
-                <a:latin typeface="DM Sans"/>
-                <a:ea typeface="DM Sans"/>
-                <a:cs typeface="DM Sans"/>
-              </a:rPr>
-              <a:t>A person measures the grain</a:t>
-            </a:r>
-          </a:p>
-          <a:p xmlns:a="http://schemas.openxmlformats.org/drawingml/2006/main">
-            <a:pPr>
-              <a:defRPr sz="1875" b="0">
-                <a:solidFill>
-                  <a:srgbClr val="667561"/>
-                </a:solidFill>
-                <a:latin typeface="DM Sans"/>
-                <a:ea typeface="DM Sans"/>
-                <a:cs typeface="DM Sans"/>
-              </a:defRPr>
-            </a:pPr>
-            <a:r>
-              <a:rPr sz="1875" b="0">
-                <a:solidFill>
-                  <a:srgbClr val="667561"/>
-                </a:solidFill>
-                <a:latin typeface="DM Sans"/>
-                <a:ea typeface="DM Sans"/>
-                <a:cs typeface="DM Sans"/>
-              </a:rPr>
-              <a:t>after the handling work.</a:t>
-            </a:r>
-          </a:p>
-        </p:txBody>
-      </p:sp>
-      <p:sp>
-        <p:nvSpPr>
-          <p:cNvPr id="11" name="04">
-            <a:extLst xmlns:a="http://schemas.openxmlformats.org/drawingml/2006/main">
-              <a:ext uri="{FF2B5EF4-FFF2-40B4-BE49-F238E27FC236}">
-                <a16:creationId xmlns:a16="http://schemas.microsoft.com/office/drawing/2014/main" id="{187800F6-D2E2-4C82-AABB-B495D8DDDA9C}"/>
-              </a:ext>
-            </a:extLst>
-          </p:cNvPr>
-          <p:cNvSpPr>
-            <a:spLocks xmlns:a="http://schemas.openxmlformats.org/drawingml/2006/main" noGrp="1"/>
-          </p:cNvSpPr>
-          <p:nvPr/>
-        </p:nvSpPr>
-        <p:spPr>
-          <a:xfrm xmlns:a="http://schemas.openxmlformats.org/drawingml/2006/main">
-            <a:off x="9115425" y="2038350"/>
-            <a:ext cx="2381250" cy="619125"/>
-          </a:xfrm>
-          <a:prstGeom xmlns:a="http://schemas.openxmlformats.org/drawingml/2006/main" prst="rect">
-            <a:avLst/>
-          </a:prstGeom>
-          <a:noFill xmlns:a="http://schemas.openxmlformats.org/drawingml/2006/main"/>
-          <a:ln xmlns:a="http://schemas.openxmlformats.org/drawingml/2006/main" w="0">
-            <a:noFill/>
-          </a:ln>
-        </p:spPr>
-        <p:txBody>
-          <a:bodyPr xmlns:a="http://schemas.openxmlformats.org/drawingml/2006/main" wrap="square" lIns="0" tIns="0" rIns="0" bIns="0">
-            <a:noAutofit/>
-          </a:bodyPr>
-          <a:lstStyle xmlns:a="http://schemas.openxmlformats.org/drawingml/2006/main"/>
-          <a:p xmlns:a="http://schemas.openxmlformats.org/drawingml/2006/main">
-            <a:pPr>
-              <a:defRPr sz="4050" b="1">
-                <a:solidFill>
-                  <a:srgbClr val="D0A650"/>
-                </a:solidFill>
-                <a:latin typeface="Manrope"/>
-                <a:ea typeface="Manrope"/>
-                <a:cs typeface="Manrope"/>
-              </a:defRPr>
-            </a:pPr>
-            <a:r>
-              <a:rPr sz="4050" b="1">
-                <a:solidFill>
-                  <a:srgbClr val="D0A650"/>
-                </a:solidFill>
-                <a:latin typeface="Manrope"/>
-                <a:ea typeface="Manrope"/>
-                <a:cs typeface="Manrope"/>
-              </a:rPr>
-              <a:t>04</a:t>
-            </a:r>
-          </a:p>
-        </p:txBody>
-      </p:sp>
-      <p:sp>
-        <p:nvSpPr>
-          <p:cNvPr id="12" name="Review the lot">
-            <a:extLst xmlns:a="http://schemas.openxmlformats.org/drawingml/2006/main">
-              <a:ext uri="{FF2B5EF4-FFF2-40B4-BE49-F238E27FC236}">
-                <a16:creationId xmlns:a16="http://schemas.microsoft.com/office/drawing/2014/main" id="{1CF6B03A-520B-489A-A3CB-3FFE4E7DFCC2}"/>
-              </a:ext>
-            </a:extLst>
-          </p:cNvPr>
-          <p:cNvSpPr>
-            <a:spLocks xmlns:a="http://schemas.openxmlformats.org/drawingml/2006/main" noGrp="1"/>
-          </p:cNvSpPr>
-          <p:nvPr/>
-        </p:nvSpPr>
-        <p:spPr>
-          <a:xfrm xmlns:a="http://schemas.openxmlformats.org/drawingml/2006/main">
-            <a:off x="9115425" y="2981325"/>
-            <a:ext cx="2476500" cy="781050"/>
-          </a:xfrm>
-          <a:prstGeom xmlns:a="http://schemas.openxmlformats.org/drawingml/2006/main" prst="rect">
-            <a:avLst/>
-          </a:prstGeom>
-          <a:noFill xmlns:a="http://schemas.openxmlformats.org/drawingml/2006/main"/>
-          <a:ln xmlns:a="http://schemas.openxmlformats.org/drawingml/2006/main" w="0">
-            <a:noFill/>
-          </a:ln>
-        </p:spPr>
-        <p:txBody>
-          <a:bodyPr xmlns:a="http://schemas.openxmlformats.org/drawingml/2006/main" wrap="square" lIns="0" tIns="0" rIns="0" bIns="0">
-            <a:noAutofit/>
-          </a:bodyPr>
-          <a:lstStyle xmlns:a="http://schemas.openxmlformats.org/drawingml/2006/main"/>
-          <a:p xmlns:a="http://schemas.openxmlformats.org/drawingml/2006/main">
-            <a:pPr>
-              <a:defRPr sz="2325" b="1">
-                <a:solidFill>
-                  <a:srgbClr val="244D37"/>
-                </a:solidFill>
-                <a:latin typeface="DM Sans"/>
-                <a:ea typeface="DM Sans"/>
-                <a:cs typeface="DM Sans"/>
-              </a:defRPr>
-            </a:pPr>
-            <a:r>
-              <a:rPr sz="2325" b="1">
-                <a:solidFill>
-                  <a:srgbClr val="244D37"/>
-                </a:solidFill>
-                <a:latin typeface="DM Sans"/>
-                <a:ea typeface="DM Sans"/>
-                <a:cs typeface="DM Sans"/>
-              </a:rPr>
-              <a:t>Review the lot</a:t>
-            </a:r>
-          </a:p>
-        </p:txBody>
-      </p:sp>
-      <p:sp>
-        <p:nvSpPr>
-          <p:cNvPr id="13" name="Recent moisture at target&#10;permits storage rev">
-            <a:extLst xmlns:a="http://schemas.openxmlformats.org/drawingml/2006/main">
-              <a:ext uri="{FF2B5EF4-FFF2-40B4-BE49-F238E27FC236}">
-                <a16:creationId xmlns:a16="http://schemas.microsoft.com/office/drawing/2014/main" id="{A37C97CA-FEA0-4EA2-95D8-68A03573E6D5}"/>
-              </a:ext>
-            </a:extLst>
-          </p:cNvPr>
-          <p:cNvSpPr>
-            <a:spLocks xmlns:a="http://schemas.openxmlformats.org/drawingml/2006/main" noGrp="1"/>
-          </p:cNvSpPr>
-          <p:nvPr/>
-        </p:nvSpPr>
-        <p:spPr>
-          <a:xfrm xmlns:a="http://schemas.openxmlformats.org/drawingml/2006/main">
-            <a:off x="9115425" y="3933825"/>
-            <a:ext cx="2409825" cy="1047750"/>
-          </a:xfrm>
-          <a:prstGeom xmlns:a="http://schemas.openxmlformats.org/drawingml/2006/main" prst="rect">
-            <a:avLst/>
-          </a:prstGeom>
-          <a:noFill xmlns:a="http://schemas.openxmlformats.org/drawingml/2006/main"/>
-          <a:ln xmlns:a="http://schemas.openxmlformats.org/drawingml/2006/main" w="0">
-            <a:noFill/>
-          </a:ln>
-        </p:spPr>
-        <p:txBody>
-          <a:bodyPr xmlns:a="http://schemas.openxmlformats.org/drawingml/2006/main" wrap="square" lIns="0" tIns="0" rIns="0" bIns="0">
-            <a:noAutofit/>
-          </a:bodyPr>
-          <a:lstStyle xmlns:a="http://schemas.openxmlformats.org/drawingml/2006/main"/>
-          <a:p xmlns:a="http://schemas.openxmlformats.org/drawingml/2006/main">
-            <a:pPr>
-              <a:defRPr sz="1875" b="0">
-                <a:solidFill>
-                  <a:srgbClr val="667561"/>
-                </a:solidFill>
-                <a:latin typeface="DM Sans"/>
-                <a:ea typeface="DM Sans"/>
-                <a:cs typeface="DM Sans"/>
-              </a:defRPr>
-            </a:pPr>
-            <a:r>
-              <a:rPr sz="1875" b="0">
-                <a:solidFill>
-                  <a:srgbClr val="667561"/>
-                </a:solidFill>
-                <a:latin typeface="DM Sans"/>
-                <a:ea typeface="DM Sans"/>
-                <a:cs typeface="DM Sans"/>
-              </a:rPr>
-              <a:t>Recent moisture at target</a:t>
-            </a:r>
-          </a:p>
-          <a:p xmlns:a="http://schemas.openxmlformats.org/drawingml/2006/main">
-            <a:pPr>
-              <a:defRPr sz="1875" b="0">
-                <a:solidFill>
-                  <a:srgbClr val="667561"/>
-                </a:solidFill>
-                <a:latin typeface="DM Sans"/>
-                <a:ea typeface="DM Sans"/>
-                <a:cs typeface="DM Sans"/>
-              </a:defRPr>
-            </a:pPr>
-            <a:r>
-              <a:rPr sz="1875" b="0">
-                <a:solidFill>
-                  <a:srgbClr val="667561"/>
-                </a:solidFill>
-                <a:latin typeface="DM Sans"/>
-                <a:ea typeface="DM Sans"/>
-                <a:cs typeface="DM Sans"/>
-              </a:rPr>
-              <a:t>permits storage review.</a:t>
-            </a:r>
-          </a:p>
-        </p:txBody>
-      </p:sp>
-      <p:sp>
-        <p:nvSpPr>
-          <p:cNvPr id="14" name="Weather suitability is an operating heuristic">
-            <a:extLst xmlns:a="http://schemas.openxmlformats.org/drawingml/2006/main">
-              <a:ext uri="{FF2B5EF4-FFF2-40B4-BE49-F238E27FC236}">
-                <a16:creationId xmlns:a16="http://schemas.microsoft.com/office/drawing/2014/main" id="{0206C309-9C04-47EE-BBB0-31C67E0C1B6F}"/>
-              </a:ext>
-            </a:extLst>
-          </p:cNvPr>
-          <p:cNvSpPr>
-            <a:spLocks xmlns:a="http://schemas.openxmlformats.org/drawingml/2006/main" noGrp="1"/>
-          </p:cNvSpPr>
-          <p:nvPr/>
-        </p:nvSpPr>
-        <p:spPr>
-          <a:xfrm xmlns:a="http://schemas.openxmlformats.org/drawingml/2006/main">
-            <a:off x="714375" y="5562600"/>
-            <a:ext cx="10572750" cy="552450"/>
-          </a:xfrm>
-          <a:prstGeom xmlns:a="http://schemas.openxmlformats.org/drawingml/2006/main" prst="rect">
-            <a:avLst/>
-          </a:prstGeom>
-          <a:noFill xmlns:a="http://schemas.openxmlformats.org/drawingml/2006/main"/>
-          <a:ln xmlns:a="http://schemas.openxmlformats.org/drawingml/2006/main" w="0">
-            <a:noFill/>
-          </a:ln>
-        </p:spPr>
-        <p:txBody>
-          <a:bodyPr xmlns:a="http://schemas.openxmlformats.org/drawingml/2006/main" wrap="square" lIns="0" tIns="0" rIns="0" bIns="0">
-            <a:noAutofit/>
-          </a:bodyPr>
-          <a:lstStyle xmlns:a="http://schemas.openxmlformats.org/drawingml/2006/main"/>
-          <a:p xmlns:a="http://schemas.openxmlformats.org/drawingml/2006/main">
-            <a:pPr>
-              <a:defRPr sz="1800" b="0">
-                <a:solidFill>
-                  <a:srgbClr val="244D37"/>
-                </a:solidFill>
-                <a:latin typeface="DM Sans"/>
-                <a:ea typeface="DM Sans"/>
-                <a:cs typeface="DM Sans"/>
-              </a:defRPr>
-            </a:pPr>
-            <a:r>
-              <a:rPr sz="1800" b="0">
-                <a:solidFill>
-                  <a:srgbClr val="244D37"/>
-                </a:solidFill>
-                <a:latin typeface="DM Sans"/>
-                <a:ea typeface="DM Sans"/>
-                <a:cs typeface="DM Sans"/>
-              </a:rPr>
-              <a:t>Weather suitability is an operating heuristic. Moisture review does not certify food safety.</a:t>
-            </a:r>
-          </a:p>
-        </p:txBody>
-      </p:sp>
-      <p:sp>
-        <p:nvSpPr>
-          <p:cNvPr id="15" name="Kavu    05">
-            <a:extLst xmlns:a="http://schemas.openxmlformats.org/drawingml/2006/main">
-              <a:ext uri="{FF2B5EF4-FFF2-40B4-BE49-F238E27FC236}">
-                <a16:creationId xmlns:a16="http://schemas.microsoft.com/office/drawing/2014/main" id="{6EB5ACE8-1B4C-4FF7-B52C-08261FD68803}"/>
-              </a:ext>
-            </a:extLst>
-          </p:cNvPr>
-          <p:cNvSpPr>
-            <a:spLocks xmlns:a="http://schemas.openxmlformats.org/drawingml/2006/main" noGrp="1"/>
-          </p:cNvSpPr>
-          <p:nvPr/>
-        </p:nvSpPr>
-        <p:spPr>
-          <a:xfrm xmlns:a="http://schemas.openxmlformats.org/drawingml/2006/main">
-            <a:off x="685800" y="6334125"/>
-            <a:ext cx="10668000" cy="228600"/>
-          </a:xfrm>
-          <a:prstGeom xmlns:a="http://schemas.openxmlformats.org/drawingml/2006/main" prst="rect">
-            <a:avLst/>
-          </a:prstGeom>
-          <a:noFill xmlns:a="http://schemas.openxmlformats.org/drawingml/2006/main"/>
-          <a:ln xmlns:a="http://schemas.openxmlformats.org/drawingml/2006/main" w="0">
-            <a:noFill/>
-          </a:ln>
-        </p:spPr>
-        <p:txBody>
-          <a:bodyPr xmlns:a="http://schemas.openxmlformats.org/drawingml/2006/main" wrap="square" lIns="0" tIns="0" rIns="0" bIns="0">
-            <a:noAutofit/>
-          </a:bodyPr>
-          <a:lstStyle xmlns:a="http://schemas.openxmlformats.org/drawingml/2006/main"/>
-          <a:p xmlns:a="http://schemas.openxmlformats.org/drawingml/2006/main">
-            <a:pPr>
               <a:defRPr sz="1200" b="0">
                 <a:solidFill>
                   <a:srgbClr val="667561"/>
@@ -4317,7 +4077,7 @@
     </p:spTree>
     <p:extLst>
       <p:ext uri="{BB962C8B-B14F-4D97-AF65-F5344CB8AC3E}">
-        <p14:creationId xmlns:p14="http://schemas.microsoft.com/office/powerpoint/2010/main" val="986285481"/>
+        <p14:creationId xmlns:p14="http://schemas.microsoft.com/office/powerpoint/2010/main" val="1877480636"/>
       </p:ext>
     </p:extLst>
   </p:cSld>
@@ -4348,7 +4108,7 @@
           <p:cNvPr id="7" name="The economics of one example">
             <a:extLst xmlns:a="http://schemas.openxmlformats.org/drawingml/2006/main">
               <a:ext uri="{FF2B5EF4-FFF2-40B4-BE49-F238E27FC236}">
-                <a16:creationId xmlns:a16="http://schemas.microsoft.com/office/drawing/2014/main" id="{5C05B8CF-17E5-4577-9EED-29FCECFFABB3}"/>
+                <a16:creationId xmlns:a16="http://schemas.microsoft.com/office/drawing/2014/main" id="{8A743F14-2E1D-4BDD-8CC3-E69F7151AA80}"/>
               </a:ext>
             </a:extLst>
           </p:cNvPr>
@@ -4402,10 +4162,10 @@
       </p:sp>
       <p:sp>
         <p:nvSpPr>
-          <p:cNvPr id="2" name="KSh 3,778">
+          <p:cNvPr id="2" name="KSh 2,176">
             <a:extLst xmlns:a="http://schemas.openxmlformats.org/drawingml/2006/main">
               <a:ext uri="{FF2B5EF4-FFF2-40B4-BE49-F238E27FC236}">
-                <a16:creationId xmlns:a16="http://schemas.microsoft.com/office/drawing/2014/main" id="{1658E8FE-343D-441B-B81F-C9CA324892AA}"/>
+                <a16:creationId xmlns:a16="http://schemas.microsoft.com/office/drawing/2014/main" id="{39675DE7-D0CD-4149-86AB-BD00F30A8EE6}"/>
               </a:ext>
             </a:extLst>
           </p:cNvPr>
@@ -4452,7 +4212,7 @@
                 <a:ea typeface="Manrope"/>
                 <a:cs typeface="Manrope"/>
               </a:rPr>
-              <a:t>KSh 3,778</a:t>
+              <a:t>KSh 2,176</a:t>
             </a:r>
           </a:p>
         </p:txBody>
@@ -4462,7 +4222,7 @@
           <p:cNvPr id="3" name="Drying-tariff equivalent">
             <a:extLst xmlns:a="http://schemas.openxmlformats.org/drawingml/2006/main">
               <a:ext uri="{FF2B5EF4-FFF2-40B4-BE49-F238E27FC236}">
-                <a16:creationId xmlns:a16="http://schemas.microsoft.com/office/drawing/2014/main" id="{74A529F0-9ABF-479F-89B9-D854FDE4D47B}"/>
+                <a16:creationId xmlns:a16="http://schemas.microsoft.com/office/drawing/2014/main" id="{DAEE4330-6A7E-4A49-8B5B-F293118B3E0E}"/>
               </a:ext>
             </a:extLst>
           </p:cNvPr>
@@ -4516,10 +4276,10 @@
       </p:sp>
       <p:sp>
         <p:nvSpPr>
-          <p:cNvPr id="4" name="5 tonnes × 2 percentage points × KSh 377.80">
+          <p:cNvPr id="4" name="1.8 tonnes × 3.2 percentage points × KSh 377.">
             <a:extLst xmlns:a="http://schemas.openxmlformats.org/drawingml/2006/main">
               <a:ext uri="{FF2B5EF4-FFF2-40B4-BE49-F238E27FC236}">
-                <a16:creationId xmlns:a16="http://schemas.microsoft.com/office/drawing/2014/main" id="{ED4A4585-7F9B-45E4-8AB2-C80C866E7339}"/>
+                <a16:creationId xmlns:a16="http://schemas.microsoft.com/office/drawing/2014/main" id="{8404FE7E-8098-4F9D-8EB6-877B3A16C8E2}"/>
               </a:ext>
             </a:extLst>
           </p:cNvPr>
@@ -4548,7 +4308,7 @@
           <a:lstStyle xmlns:a="http://schemas.openxmlformats.org/drawingml/2006/main"/>
           <a:p xmlns:a="http://schemas.openxmlformats.org/drawingml/2006/main">
             <a:pPr>
-              <a:defRPr sz="2475" b="0">
+              <a:defRPr sz="2325" b="0">
                 <a:solidFill>
                   <a:srgbClr val="244D37"/>
                 </a:solidFill>
@@ -4558,7 +4318,7 @@
               </a:defRPr>
             </a:pPr>
             <a:r>
-              <a:rPr sz="2475" b="0">
+              <a:rPr sz="2325" b="0">
                 <a:solidFill>
                   <a:srgbClr val="244D37"/>
                 </a:solidFill>
@@ -4566,17 +4326,17 @@
                 <a:ea typeface="DM Sans"/>
                 <a:cs typeface="DM Sans"/>
               </a:rPr>
-              <a:t>5 tonnes × 2 percentage points × KSh 377.80</a:t>
-            </a:r>
-          </a:p>
-        </p:txBody>
-      </p:sp>
-      <p:sp>
-        <p:nvSpPr>
-          <p:cNvPr id="5" name="Example moisture: 17% to 15%&#10;Labour, transpor">
+              <a:t>1.8 tonnes × 3.2 percentage points × KSh 377.80</a:t>
+            </a:r>
+          </a:p>
+        </p:txBody>
+      </p:sp>
+      <p:sp>
+        <p:nvSpPr>
+          <p:cNvPr id="5" name="Mavuno A-01 example: 18.2% to 15.0%&#10;Actual sa">
             <a:extLst xmlns:a="http://schemas.openxmlformats.org/drawingml/2006/main">
               <a:ext uri="{FF2B5EF4-FFF2-40B4-BE49-F238E27FC236}">
-                <a16:creationId xmlns:a16="http://schemas.microsoft.com/office/drawing/2014/main" id="{D2F6FC4A-1D67-452F-BB42-6EEF7B1F10C2}"/>
+                <a16:creationId xmlns:a16="http://schemas.microsoft.com/office/drawing/2014/main" id="{33EA65AA-39E7-4BD7-9095-41E6130B8238}"/>
               </a:ext>
             </a:extLst>
           </p:cNvPr>
@@ -4623,7 +4383,7 @@
                 <a:ea typeface="DM Sans"/>
                 <a:cs typeface="DM Sans"/>
               </a:rPr>
-              <a:t>Example moisture: 17% to 15%</a:t>
+              <a:t>Mavuno A-01 example: 18.2% to 15.0%</a:t>
             </a:r>
           </a:p>
           <a:p xmlns:a="http://schemas.openxmlformats.org/drawingml/2006/main">
@@ -4646,7 +4406,7 @@
                 <a:ea typeface="DM Sans"/>
                 <a:cs typeface="DM Sans"/>
               </a:rPr>
-              <a:t>Labour, transport and causal savings are outside this comparison.</a:t>
+              <a:t>Actual savings need labour, transport and alternative cost records.</a:t>
             </a:r>
           </a:p>
         </p:txBody>
@@ -4656,7 +4416,7 @@
           <p:cNvPr id="6" name="Kavu    06">
             <a:extLst xmlns:a="http://schemas.openxmlformats.org/drawingml/2006/main">
               <a:ext uri="{FF2B5EF4-FFF2-40B4-BE49-F238E27FC236}">
-                <a16:creationId xmlns:a16="http://schemas.microsoft.com/office/drawing/2014/main" id="{17DA0C5F-AE6A-4F80-8BC1-17EE61CA3703}"/>
+                <a16:creationId xmlns:a16="http://schemas.microsoft.com/office/drawing/2014/main" id="{52CA0579-7A1D-42D5-A5CC-075E507592B2}"/>
               </a:ext>
             </a:extLst>
           </p:cNvPr>
@@ -4711,7 +4471,7 @@
     </p:spTree>
     <p:extLst>
       <p:ext uri="{BB962C8B-B14F-4D97-AF65-F5344CB8AC3E}">
-        <p14:creationId xmlns:p14="http://schemas.microsoft.com/office/powerpoint/2010/main" val="1007776328"/>
+        <p14:creationId xmlns:p14="http://schemas.microsoft.com/office/powerpoint/2010/main" val="884613594"/>
       </p:ext>
     </p:extLst>
   </p:cSld>
@@ -4742,7 +4502,7 @@
           <p:cNvPr id="9" name="A co-op buyer, a price to test">
             <a:extLst xmlns:a="http://schemas.openxmlformats.org/drawingml/2006/main">
               <a:ext uri="{FF2B5EF4-FFF2-40B4-BE49-F238E27FC236}">
-                <a16:creationId xmlns:a16="http://schemas.microsoft.com/office/drawing/2014/main" id="{AF14EDAC-0870-4E18-A01C-A457499B505E}"/>
+                <a16:creationId xmlns:a16="http://schemas.microsoft.com/office/drawing/2014/main" id="{EA8A6837-2DA2-49BE-806E-00405AD425DB}"/>
               </a:ext>
             </a:extLst>
           </p:cNvPr>
@@ -4799,7 +4559,7 @@
           <p:cNvPr id="2" name="One supervisor.&#10;Many farmers’ lots.">
             <a:extLst xmlns:a="http://schemas.openxmlformats.org/drawingml/2006/main">
               <a:ext uri="{FF2B5EF4-FFF2-40B4-BE49-F238E27FC236}">
-                <a16:creationId xmlns:a16="http://schemas.microsoft.com/office/drawing/2014/main" id="{E1B15978-91FB-4EE0-9B14-F4ECE7CB23BE}"/>
+                <a16:creationId xmlns:a16="http://schemas.microsoft.com/office/drawing/2014/main" id="{A147AFC3-6394-47A5-8862-BCC155C7B8EF}"/>
               </a:ext>
             </a:extLst>
           </p:cNvPr>
@@ -4876,10 +4636,10 @@
       </p:sp>
       <p:sp>
         <p:nvSpPr>
-          <p:cNvPr id="3" name="The incumbent is a weather report&#10;and a noteb">
+          <p:cNvPr id="3" name="The daily alternative is a weather&#10;report and">
             <a:extLst xmlns:a="http://schemas.openxmlformats.org/drawingml/2006/main">
               <a:ext uri="{FF2B5EF4-FFF2-40B4-BE49-F238E27FC236}">
-                <a16:creationId xmlns:a16="http://schemas.microsoft.com/office/drawing/2014/main" id="{5267A6F9-AE7A-4380-97ED-755296263373}"/>
+                <a16:creationId xmlns:a16="http://schemas.microsoft.com/office/drawing/2014/main" id="{1A4988E3-8946-4FC4-A6C0-8CEC69127B93}"/>
               </a:ext>
             </a:extLst>
           </p:cNvPr>
@@ -4926,7 +4686,7 @@
                 <a:ea typeface="DM Sans"/>
                 <a:cs typeface="DM Sans"/>
               </a:rPr>
-              <a:t>The incumbent is a weather report</a:t>
+              <a:t>The daily alternative is a weather</a:t>
             </a:r>
           </a:p>
           <a:p xmlns:a="http://schemas.openxmlformats.org/drawingml/2006/main">
@@ -4949,7 +4709,7 @@
                 <a:ea typeface="DM Sans"/>
                 <a:cs typeface="DM Sans"/>
               </a:rPr>
-              <a:t>and a notebook. Kavu must earn its</a:t>
+              <a:t>report and a notebook. Renewal</a:t>
             </a:r>
           </a:p>
           <a:p xmlns:a="http://schemas.openxmlformats.org/drawingml/2006/main">
@@ -4972,7 +4732,7 @@
                 <a:ea typeface="DM Sans"/>
                 <a:cs typeface="DM Sans"/>
               </a:rPr>
-              <a:t>place in that daily workflow.</a:t>
+              <a:t>depends on easier handovers.</a:t>
             </a:r>
           </a:p>
         </p:txBody>
@@ -4982,7 +4742,7 @@
           <p:cNvPr id="4" name="KSh 2,500">
             <a:extLst xmlns:a="http://schemas.openxmlformats.org/drawingml/2006/main">
               <a:ext uri="{FF2B5EF4-FFF2-40B4-BE49-F238E27FC236}">
-                <a16:creationId xmlns:a16="http://schemas.microsoft.com/office/drawing/2014/main" id="{9AFCDB02-5DBC-4126-AE0A-6FD233D90078}"/>
+                <a16:creationId xmlns:a16="http://schemas.microsoft.com/office/drawing/2014/main" id="{37403918-60D7-4CCB-BF35-299066B0A487}"/>
               </a:ext>
             </a:extLst>
           </p:cNvPr>
@@ -5039,7 +4799,7 @@
           <p:cNvPr id="5" name="per active month per site">
             <a:extLst xmlns:a="http://schemas.openxmlformats.org/drawingml/2006/main">
               <a:ext uri="{FF2B5EF4-FFF2-40B4-BE49-F238E27FC236}">
-                <a16:creationId xmlns:a16="http://schemas.microsoft.com/office/drawing/2014/main" id="{60EE93C3-F235-4EE2-AD14-CEFAC76B7722}"/>
+                <a16:creationId xmlns:a16="http://schemas.microsoft.com/office/drawing/2014/main" id="{BCC905D1-F798-4ABA-B17B-B0B6453E1FCE}"/>
               </a:ext>
             </a:extLst>
           </p:cNvPr>
@@ -5093,10 +4853,10 @@
       </p:sp>
       <p:sp>
         <p:nvSpPr>
-          <p:cNvPr id="6" name="Pricing hypothesis&#10;No paying customers claime">
+          <p:cNvPr id="6" name="Price to test in a pilot&#10;Track support effort">
             <a:extLst xmlns:a="http://schemas.openxmlformats.org/drawingml/2006/main">
               <a:ext uri="{FF2B5EF4-FFF2-40B4-BE49-F238E27FC236}">
-                <a16:creationId xmlns:a16="http://schemas.microsoft.com/office/drawing/2014/main" id="{812C3AE3-6042-4CDC-A6E4-27F94D11FEC4}"/>
+                <a16:creationId xmlns:a16="http://schemas.microsoft.com/office/drawing/2014/main" id="{1BC216B7-B01B-4000-AE01-71B6D8571D3E}"/>
               </a:ext>
             </a:extLst>
           </p:cNvPr>
@@ -5143,7 +4903,7 @@
                 <a:ea typeface="DM Sans"/>
                 <a:cs typeface="DM Sans"/>
               </a:rPr>
-              <a:t>Pricing hypothesis</a:t>
+              <a:t>Price to test in a pilot</a:t>
             </a:r>
           </a:p>
           <a:p xmlns:a="http://schemas.openxmlformats.org/drawingml/2006/main">
@@ -5166,17 +4926,17 @@
                 <a:ea typeface="DM Sans"/>
                 <a:cs typeface="DM Sans"/>
               </a:rPr>
-              <a:t>No paying customers claimed</a:t>
-            </a:r>
-          </a:p>
-        </p:txBody>
-      </p:sp>
-      <p:sp>
-        <p:nvSpPr>
-          <p:cNvPr id="7" name="Complements moisture meters and dryers. Poten">
+              <a:t>Track support effort and renewal</a:t>
+            </a:r>
+          </a:p>
+        </p:txBody>
+      </p:sp>
+      <p:sp>
+        <p:nvSpPr>
+          <p:cNvPr id="7" name="Start with yards that already use moisture me">
             <a:extLst xmlns:a="http://schemas.openxmlformats.org/drawingml/2006/main">
               <a:ext uri="{FF2B5EF4-FFF2-40B4-BE49-F238E27FC236}">
-                <a16:creationId xmlns:a16="http://schemas.microsoft.com/office/drawing/2014/main" id="{707C04B1-2421-4E32-8086-F17ADBE69834}"/>
+                <a16:creationId xmlns:a16="http://schemas.microsoft.com/office/drawing/2014/main" id="{A8373B38-84F9-4A7F-9DB9-BB986A6AB6BF}"/>
               </a:ext>
             </a:extLst>
           </p:cNvPr>
@@ -5223,7 +4983,7 @@
                 <a:ea typeface="DM Sans"/>
                 <a:cs typeface="DM Sans"/>
               </a:rPr>
-              <a:t>Complements moisture meters and dryers. Potential advantage: permissioned lot and cost histories.</a:t>
+              <a:t>Start with yards that already use moisture meters. Grow through useful lot and cost histories.</a:t>
             </a:r>
           </a:p>
         </p:txBody>
@@ -5233,7 +4993,7 @@
           <p:cNvPr id="8" name="Kavu    07">
             <a:extLst xmlns:a="http://schemas.openxmlformats.org/drawingml/2006/main">
               <a:ext uri="{FF2B5EF4-FFF2-40B4-BE49-F238E27FC236}">
-                <a16:creationId xmlns:a16="http://schemas.microsoft.com/office/drawing/2014/main" id="{3A349902-6D5B-4034-B7EB-EC5C67D900E8}"/>
+                <a16:creationId xmlns:a16="http://schemas.microsoft.com/office/drawing/2014/main" id="{DE44526C-4CD2-4BF6-B0E1-DC2CC1668A22}"/>
               </a:ext>
             </a:extLst>
           </p:cNvPr>
@@ -5288,7 +5048,7 @@
     </p:spTree>
     <p:extLst>
       <p:ext uri="{BB962C8B-B14F-4D97-AF65-F5344CB8AC3E}">
-        <p14:creationId xmlns:p14="http://schemas.microsoft.com/office/powerpoint/2010/main" val="523723059"/>
+        <p14:creationId xmlns:p14="http://schemas.microsoft.com/office/powerpoint/2010/main" val="1530323712"/>
       </p:ext>
     </p:extLst>
   </p:cSld>
@@ -5319,7 +5079,7 @@
           <p:cNvPr id="6" name="The next test is in the yard">
             <a:extLst xmlns:a="http://schemas.openxmlformats.org/drawingml/2006/main">
               <a:ext uri="{FF2B5EF4-FFF2-40B4-BE49-F238E27FC236}">
-                <a16:creationId xmlns:a16="http://schemas.microsoft.com/office/drawing/2014/main" id="{A5900CA6-C4D1-4E8D-8838-98C7A7BD76E5}"/>
+                <a16:creationId xmlns:a16="http://schemas.microsoft.com/office/drawing/2014/main" id="{79B4C285-EF72-4859-808B-9F8FDF54F7D7}"/>
               </a:ext>
             </a:extLst>
           </p:cNvPr>
@@ -5373,10 +5133,10 @@
       </p:sp>
       <p:sp>
         <p:nvSpPr>
-          <p:cNvPr id="2" name="A supervised pilot&#10;with three maize yards">
+          <p:cNvPr id="2" name="A supervised pilot&#10;with up to three yards">
             <a:extLst xmlns:a="http://schemas.openxmlformats.org/drawingml/2006/main">
               <a:ext uri="{FF2B5EF4-FFF2-40B4-BE49-F238E27FC236}">
-                <a16:creationId xmlns:a16="http://schemas.microsoft.com/office/drawing/2014/main" id="{44E231E6-31D9-4721-90EE-ABEDD610FDA3}"/>
+                <a16:creationId xmlns:a16="http://schemas.microsoft.com/office/drawing/2014/main" id="{05866B87-1D09-4BC9-89DA-26B28CCA2195}"/>
               </a:ext>
             </a:extLst>
           </p:cNvPr>
@@ -5446,17 +5206,17 @@
                 <a:ea typeface="Manrope"/>
                 <a:cs typeface="Manrope"/>
               </a:rPr>
-              <a:t>with three maize yards</a:t>
-            </a:r>
-          </a:p>
-        </p:txBody>
-      </p:sp>
-      <p:sp>
-        <p:nvSpPr>
-          <p:cNvPr id="3" name="Observe current work first.&#10;Compare recommend">
+              <a:t>with up to three yards</a:t>
+            </a:r>
+          </a:p>
+        </p:txBody>
+      </p:sp>
+      <p:sp>
+        <p:nvSpPr>
+          <p:cNvPr id="3" name="Observe the operator, then run in shadow mode">
             <a:extLst xmlns:a="http://schemas.openxmlformats.org/drawingml/2006/main">
               <a:ext uri="{FF2B5EF4-FFF2-40B4-BE49-F238E27FC236}">
-                <a16:creationId xmlns:a16="http://schemas.microsoft.com/office/drawing/2014/main" id="{07D4A776-5812-4B21-85E1-290D947FD8A5}"/>
+                <a16:creationId xmlns:a16="http://schemas.microsoft.com/office/drawing/2014/main" id="{0242BF5F-7B6B-4AF8-A0F8-ED29F09EE074}"/>
               </a:ext>
             </a:extLst>
           </p:cNvPr>
@@ -5503,7 +5263,7 @@
                 <a:ea typeface="DM Sans"/>
                 <a:cs typeface="DM Sans"/>
               </a:rPr>
-              <a:t>Observe current work first.</a:t>
+              <a:t>Observe the operator, then run in shadow mode.</a:t>
             </a:r>
           </a:p>
           <a:p xmlns:a="http://schemas.openxmlformats.org/drawingml/2006/main">
@@ -5526,7 +5286,7 @@
                 <a:ea typeface="DM Sans"/>
                 <a:cs typeface="DM Sans"/>
               </a:rPr>
-              <a:t>Compare recommendations in shadow mode.</a:t>
+              <a:t>Measure handovers, moisture checks and actual costs.</a:t>
             </a:r>
           </a:p>
           <a:p xmlns:a="http://schemas.openxmlformats.org/drawingml/2006/main">
@@ -5549,7 +5309,7 @@
                 <a:ea typeface="DM Sans"/>
                 <a:cs typeface="DM Sans"/>
               </a:rPr>
-              <a:t>Measure adoption, rechecks and actual costs.</a:t>
+              <a:t>Test continued use and willingness to renew.</a:t>
             </a:r>
           </a:p>
         </p:txBody>
@@ -5559,7 +5319,7 @@
           <p:cNvPr id="4" name="Seeking operator feedback and pilot introduct">
             <a:extLst xmlns:a="http://schemas.openxmlformats.org/drawingml/2006/main">
               <a:ext uri="{FF2B5EF4-FFF2-40B4-BE49-F238E27FC236}">
-                <a16:creationId xmlns:a16="http://schemas.microsoft.com/office/drawing/2014/main" id="{E581CF4D-FD58-4183-B1DE-5F5735977283}"/>
+                <a16:creationId xmlns:a16="http://schemas.microsoft.com/office/drawing/2014/main" id="{B55DF3E6-7DCD-498D-A751-ABBB52031529}"/>
               </a:ext>
             </a:extLst>
           </p:cNvPr>
@@ -5616,7 +5376,7 @@
           <p:cNvPr id="5" name="Kavu    08">
             <a:extLst xmlns:a="http://schemas.openxmlformats.org/drawingml/2006/main">
               <a:ext uri="{FF2B5EF4-FFF2-40B4-BE49-F238E27FC236}">
-                <a16:creationId xmlns:a16="http://schemas.microsoft.com/office/drawing/2014/main" id="{2A7D016C-A537-4D7C-93D9-88553CE7D0D5}"/>
+                <a16:creationId xmlns:a16="http://schemas.microsoft.com/office/drawing/2014/main" id="{52C99230-6E29-4E8A-96D3-5E73B0AE5AF8}"/>
               </a:ext>
             </a:extLst>
           </p:cNvPr>
@@ -5671,7 +5431,7 @@
     </p:spTree>
     <p:extLst>
       <p:ext uri="{BB962C8B-B14F-4D97-AF65-F5344CB8AC3E}">
-        <p14:creationId xmlns:p14="http://schemas.microsoft.com/office/powerpoint/2010/main" val="460759920"/>
+        <p14:creationId xmlns:p14="http://schemas.microsoft.com/office/powerpoint/2010/main" val="1355723645"/>
       </p:ext>
     </p:extLst>
   </p:cSld>

</xml_diff>